<commit_message>
feat: add real images to PPTX and HTML, more examples and details
</commit_message>
<xml_diff>
--- a/AI_Presentation_Ayoub_Assouar.pptx
+++ b/AI_Presentation_Ayoub_Assouar.pptx
@@ -3150,16 +3150,83 @@
           </a:p>
         </p:txBody>
       </p:sp>
-      <p:sp>
-        <p:nvSpPr>
-          <p:cNvPr id="3" name="TextBox 2"/>
+      <p:pic>
+        <p:nvPicPr>
+          <p:cNvPr id="3" name="Picture 2" descr="ai-brain.jpg"/>
+          <p:cNvPicPr>
+            <a:picLocks noChangeAspect="1"/>
+          </p:cNvPicPr>
+          <p:nvPr/>
+        </p:nvPicPr>
+        <p:blipFill>
+          <a:blip r:embed="rId2"/>
+          <a:stretch>
+            <a:fillRect/>
+          </a:stretch>
+        </p:blipFill>
+        <p:spPr>
+          <a:xfrm>
+            <a:off x="7772400" y="1371600"/>
+            <a:ext cx="4114800" cy="2318004"/>
+          </a:xfrm>
+          <a:prstGeom prst="rect">
+            <a:avLst/>
+          </a:prstGeom>
+        </p:spPr>
+      </p:pic>
+      <p:sp>
+        <p:nvSpPr>
+          <p:cNvPr id="4" name="Rounded Rectangle 3"/>
+          <p:cNvSpPr/>
+          <p:nvPr/>
+        </p:nvSpPr>
+        <p:spPr>
+          <a:xfrm>
+            <a:off x="0" y="0"/>
+            <a:ext cx="7772400" cy="6858000"/>
+          </a:xfrm>
+          <a:prstGeom prst="roundRect">
+            <a:avLst/>
+          </a:prstGeom>
+          <a:solidFill>
+            <a:srgbClr val="0F0C29"/>
+          </a:solidFill>
+          <a:ln>
+            <a:noFill/>
+          </a:ln>
+        </p:spPr>
+        <p:style>
+          <a:lnRef idx="1">
+            <a:schemeClr val="accent1"/>
+          </a:lnRef>
+          <a:fillRef idx="3">
+            <a:schemeClr val="accent1"/>
+          </a:fillRef>
+          <a:effectRef idx="2">
+            <a:schemeClr val="accent1"/>
+          </a:effectRef>
+          <a:fontRef idx="minor">
+            <a:schemeClr val="lt1"/>
+          </a:fontRef>
+        </p:style>
+        <p:txBody>
+          <a:bodyPr rtlCol="0" anchor="ctr"/>
+          <a:lstStyle/>
+          <a:p>
+            <a:pPr algn="ctr"/>
+          </a:p>
+        </p:txBody>
+      </p:sp>
+      <p:sp>
+        <p:nvSpPr>
+          <p:cNvPr id="5" name="TextBox 4"/>
           <p:cNvSpPr txBox="1"/>
           <p:nvPr/>
         </p:nvSpPr>
         <p:spPr>
           <a:xfrm>
-            <a:off x="5029200" y="914400"/>
-            <a:ext cx="2286000" cy="1097280"/>
+            <a:off x="731520" y="1371600"/>
+            <a:ext cx="6400800" cy="1371600"/>
           </a:xfrm>
           <a:prstGeom prst="rect">
             <a:avLst/>
@@ -3172,30 +3239,30 @@
           </a:bodyPr>
           <a:lstStyle/>
           <a:p>
-            <a:pPr algn="ctr">
-              <a:defRPr sz="7200" b="1">
-                <a:solidFill>
-                  <a:srgbClr val="818CF8"/>
-                </a:solidFill>
-                <a:latin typeface="Calibri"/>
-              </a:defRPr>
-            </a:pPr>
-            <a:r>
-              <a:t>AI</a:t>
-            </a:r>
-          </a:p>
-        </p:txBody>
-      </p:sp>
-      <p:sp>
-        <p:nvSpPr>
-          <p:cNvPr id="4" name="TextBox 3"/>
+            <a:pPr algn="l">
+              <a:defRPr sz="4800" b="1">
+                <a:solidFill>
+                  <a:srgbClr val="FFFFFF"/>
+                </a:solidFill>
+                <a:latin typeface="Calibri"/>
+              </a:defRPr>
+            </a:pPr>
+            <a:r>
+              <a:t>L'Intelligence Artificielle</a:t>
+            </a:r>
+          </a:p>
+        </p:txBody>
+      </p:sp>
+      <p:sp>
+        <p:nvSpPr>
+          <p:cNvPr id="6" name="TextBox 5"/>
           <p:cNvSpPr txBox="1"/>
           <p:nvPr/>
         </p:nvSpPr>
         <p:spPr>
           <a:xfrm>
-            <a:off x="1371600" y="2103120"/>
-            <a:ext cx="9418320" cy="1371600"/>
+            <a:off x="731520" y="2743200"/>
+            <a:ext cx="6400800" cy="731520"/>
           </a:xfrm>
           <a:prstGeom prst="rect">
             <a:avLst/>
@@ -3208,43 +3275,7 @@
           </a:bodyPr>
           <a:lstStyle/>
           <a:p>
-            <a:pPr algn="ctr">
-              <a:defRPr sz="4800" b="1">
-                <a:solidFill>
-                  <a:srgbClr val="FFFFFF"/>
-                </a:solidFill>
-                <a:latin typeface="Calibri"/>
-              </a:defRPr>
-            </a:pPr>
-            <a:r>
-              <a:t>L'Intelligence Artificielle</a:t>
-            </a:r>
-          </a:p>
-        </p:txBody>
-      </p:sp>
-      <p:sp>
-        <p:nvSpPr>
-          <p:cNvPr id="5" name="TextBox 4"/>
-          <p:cNvSpPr txBox="1"/>
-          <p:nvPr/>
-        </p:nvSpPr>
-        <p:spPr>
-          <a:xfrm>
-            <a:off x="1828800" y="3291840"/>
-            <a:ext cx="8503920" cy="731520"/>
-          </a:xfrm>
-          <a:prstGeom prst="rect">
-            <a:avLst/>
-          </a:prstGeom>
-          <a:noFill/>
-        </p:spPr>
-        <p:txBody>
-          <a:bodyPr wrap="square">
-            <a:spAutoFit/>
-          </a:bodyPr>
-          <a:lstStyle/>
-          <a:p>
-            <a:pPr algn="ctr">
+            <a:pPr algn="l">
               <a:defRPr sz="2400" b="0">
                 <a:solidFill>
                   <a:srgbClr val="B3B3B3"/>
@@ -3260,14 +3291,14 @@
       </p:sp>
       <p:sp>
         <p:nvSpPr>
-          <p:cNvPr id="6" name="Rounded Rectangle 5"/>
+          <p:cNvPr id="7" name="Rounded Rectangle 6"/>
           <p:cNvSpPr/>
           <p:nvPr/>
         </p:nvSpPr>
         <p:spPr>
           <a:xfrm>
-            <a:off x="3657600" y="4389120"/>
-            <a:ext cx="4846320" cy="1645920"/>
+            <a:off x="731520" y="3931920"/>
+            <a:ext cx="5029200" cy="1828800"/>
           </a:xfrm>
           <a:prstGeom prst="roundRect">
             <a:avLst>
@@ -3305,13 +3336,13 @@
       </p:sp>
       <p:sp>
         <p:nvSpPr>
-          <p:cNvPr id="7" name="TextBox 6"/>
+          <p:cNvPr id="8" name="TextBox 7"/>
           <p:cNvSpPr txBox="1"/>
           <p:nvPr/>
         </p:nvSpPr>
         <p:spPr>
           <a:xfrm>
-            <a:off x="3840480" y="4480560"/>
+            <a:off x="1005840" y="4114800"/>
             <a:ext cx="4572000" cy="457200"/>
           </a:xfrm>
           <a:prstGeom prst="rect">
@@ -3325,7 +3356,7 @@
           </a:bodyPr>
           <a:lstStyle/>
           <a:p>
-            <a:pPr algn="ctr">
+            <a:pPr algn="l">
               <a:defRPr sz="1600" b="0">
                 <a:solidFill>
                   <a:srgbClr val="B3B3B3"/>
@@ -3341,13 +3372,13 @@
       </p:sp>
       <p:sp>
         <p:nvSpPr>
-          <p:cNvPr id="8" name="TextBox 7"/>
+          <p:cNvPr id="9" name="TextBox 8"/>
           <p:cNvSpPr txBox="1"/>
           <p:nvPr/>
         </p:nvSpPr>
         <p:spPr>
           <a:xfrm>
-            <a:off x="3840480" y="4846320"/>
+            <a:off x="1005840" y="4480560"/>
             <a:ext cx="4572000" cy="548640"/>
           </a:xfrm>
           <a:prstGeom prst="rect">
@@ -3361,8 +3392,8 @@
           </a:bodyPr>
           <a:lstStyle/>
           <a:p>
-            <a:pPr algn="ctr">
-              <a:defRPr sz="2800" b="1">
+            <a:pPr algn="l">
+              <a:defRPr sz="3000" b="1">
                 <a:solidFill>
                   <a:srgbClr val="C084FC"/>
                 </a:solidFill>
@@ -3377,13 +3408,13 @@
       </p:sp>
       <p:sp>
         <p:nvSpPr>
-          <p:cNvPr id="9" name="TextBox 8"/>
+          <p:cNvPr id="10" name="TextBox 9"/>
           <p:cNvSpPr txBox="1"/>
           <p:nvPr/>
         </p:nvSpPr>
         <p:spPr>
           <a:xfrm>
-            <a:off x="3840480" y="5394960"/>
+            <a:off x="1005840" y="5029200"/>
             <a:ext cx="4572000" cy="457200"/>
           </a:xfrm>
           <a:prstGeom prst="rect">
@@ -3397,7 +3428,7 @@
           </a:bodyPr>
           <a:lstStyle/>
           <a:p>
-            <a:pPr algn="ctr">
+            <a:pPr algn="l">
               <a:defRPr sz="1600" b="0">
                 <a:solidFill>
                   <a:srgbClr val="808080"/>
@@ -3413,7 +3444,7 @@
       </p:sp>
       <p:sp>
         <p:nvSpPr>
-          <p:cNvPr id="10" name="Rounded Rectangle 9"/>
+          <p:cNvPr id="11" name="Rounded Rectangle 10"/>
           <p:cNvSpPr/>
           <p:nvPr/>
         </p:nvSpPr>
@@ -3595,16 +3626,40 @@
           </a:p>
         </p:txBody>
       </p:sp>
-      <p:sp>
-        <p:nvSpPr>
-          <p:cNvPr id="5" name="TextBox 4"/>
+      <p:pic>
+        <p:nvPicPr>
+          <p:cNvPr id="5" name="Picture 4" descr="ai-future.jpg"/>
+          <p:cNvPicPr>
+            <a:picLocks noChangeAspect="1"/>
+          </p:cNvPicPr>
+          <p:nvPr/>
+        </p:nvPicPr>
+        <p:blipFill>
+          <a:blip r:embed="rId2"/>
+          <a:stretch>
+            <a:fillRect/>
+          </a:stretch>
+        </p:blipFill>
+        <p:spPr>
+          <a:xfrm>
+            <a:off x="7772400" y="1645920"/>
+            <a:ext cx="4114800" cy="5143500"/>
+          </a:xfrm>
+          <a:prstGeom prst="rect">
+            <a:avLst/>
+          </a:prstGeom>
+        </p:spPr>
+      </p:pic>
+      <p:sp>
+        <p:nvSpPr>
+          <p:cNvPr id="6" name="TextBox 5"/>
           <p:cNvSpPr txBox="1"/>
           <p:nvPr/>
         </p:nvSpPr>
         <p:spPr>
           <a:xfrm>
             <a:off x="731520" y="1645920"/>
-            <a:ext cx="6400800" cy="548640"/>
+            <a:ext cx="6400800" cy="457200"/>
           </a:xfrm>
           <a:prstGeom prst="rect">
             <a:avLst/>
@@ -3626,21 +3681,21 @@
               </a:defRPr>
             </a:pPr>
             <a:r>
-              <a:t>L'IA continue d'evoluer a une vitesse impressionnante. Voici quelques tendances :</a:t>
-            </a:r>
-          </a:p>
-        </p:txBody>
-      </p:sp>
-      <p:sp>
-        <p:nvSpPr>
-          <p:cNvPr id="6" name="Rounded Rectangle 5"/>
+              <a:t>Tendances pour les prochaines annees :</a:t>
+            </a:r>
+          </a:p>
+        </p:txBody>
+      </p:sp>
+      <p:sp>
+        <p:nvSpPr>
+          <p:cNvPr id="7" name="Rounded Rectangle 6"/>
           <p:cNvSpPr/>
           <p:nvPr/>
         </p:nvSpPr>
         <p:spPr>
           <a:xfrm>
-            <a:off x="731520" y="2468880"/>
-            <a:ext cx="10698480" cy="822960"/>
+            <a:off x="548640" y="2286000"/>
+            <a:ext cx="6858000" cy="731520"/>
           </a:xfrm>
           <a:prstGeom prst="roundRect">
             <a:avLst>
@@ -3678,13 +3733,13 @@
       </p:sp>
       <p:sp>
         <p:nvSpPr>
-          <p:cNvPr id="7" name="Oval 6"/>
+          <p:cNvPr id="8" name="Oval 7"/>
           <p:cNvSpPr/>
           <p:nvPr/>
         </p:nvSpPr>
         <p:spPr>
           <a:xfrm>
-            <a:off x="1097280" y="2743200"/>
+            <a:off x="822960" y="2514600"/>
             <a:ext cx="274320" cy="274320"/>
           </a:xfrm>
           <a:prstGeom prst="ellipse">
@@ -3721,14 +3776,14 @@
       </p:sp>
       <p:sp>
         <p:nvSpPr>
-          <p:cNvPr id="8" name="TextBox 7"/>
+          <p:cNvPr id="9" name="TextBox 8"/>
           <p:cNvSpPr txBox="1"/>
           <p:nvPr/>
         </p:nvSpPr>
         <p:spPr>
           <a:xfrm>
-            <a:off x="1645920" y="2606040"/>
-            <a:ext cx="2743200" cy="457200"/>
+            <a:off x="1371600" y="2359152"/>
+            <a:ext cx="2286000" cy="365760"/>
           </a:xfrm>
           <a:prstGeom prst="rect">
             <a:avLst/>
@@ -3742,7 +3797,7 @@
           <a:lstStyle/>
           <a:p>
             <a:pPr algn="l">
-              <a:defRPr sz="1800" b="1">
+              <a:defRPr sz="1500" b="1">
                 <a:solidFill>
                   <a:srgbClr val="C084FC"/>
                 </a:solidFill>
@@ -3757,14 +3812,14 @@
       </p:sp>
       <p:sp>
         <p:nvSpPr>
-          <p:cNvPr id="9" name="TextBox 8"/>
+          <p:cNvPr id="10" name="TextBox 9"/>
           <p:cNvSpPr txBox="1"/>
           <p:nvPr/>
         </p:nvSpPr>
         <p:spPr>
           <a:xfrm>
-            <a:off x="4389120" y="2651760"/>
-            <a:ext cx="6858000" cy="457200"/>
+            <a:off x="1371600" y="2651760"/>
+            <a:ext cx="5852160" cy="320040"/>
           </a:xfrm>
           <a:prstGeom prst="rect">
             <a:avLst/>
@@ -3778,7 +3833,7 @@
           <a:lstStyle/>
           <a:p>
             <a:pPr algn="l">
-              <a:defRPr sz="1600" b="0">
+              <a:defRPr sz="1200" b="0">
                 <a:solidFill>
                   <a:srgbClr val="B3B3B3"/>
                 </a:solidFill>
@@ -3786,21 +3841,21 @@
               </a:defRPr>
             </a:pPr>
             <a:r>
-              <a:t>Creation de textes, images, videos et musique de plus en plus realistes</a:t>
-            </a:r>
-          </a:p>
-        </p:txBody>
-      </p:sp>
-      <p:sp>
-        <p:nvSpPr>
-          <p:cNvPr id="10" name="Rounded Rectangle 9"/>
+              <a:t>Textes, images, videos et musique crees par IA - de plus en plus realistes</a:t>
+            </a:r>
+          </a:p>
+        </p:txBody>
+      </p:sp>
+      <p:sp>
+        <p:nvSpPr>
+          <p:cNvPr id="11" name="Rounded Rectangle 10"/>
           <p:cNvSpPr/>
           <p:nvPr/>
         </p:nvSpPr>
         <p:spPr>
           <a:xfrm>
-            <a:off x="731520" y="3474720"/>
-            <a:ext cx="10698480" cy="822960"/>
+            <a:off x="548640" y="3154680"/>
+            <a:ext cx="6858000" cy="731520"/>
           </a:xfrm>
           <a:prstGeom prst="roundRect">
             <a:avLst>
@@ -3838,13 +3893,13 @@
       </p:sp>
       <p:sp>
         <p:nvSpPr>
-          <p:cNvPr id="11" name="Oval 10"/>
+          <p:cNvPr id="12" name="Oval 11"/>
           <p:cNvSpPr/>
           <p:nvPr/>
         </p:nvSpPr>
         <p:spPr>
           <a:xfrm>
-            <a:off x="1097280" y="3749040"/>
+            <a:off x="822960" y="3383280"/>
             <a:ext cx="274320" cy="274320"/>
           </a:xfrm>
           <a:prstGeom prst="ellipse">
@@ -3881,14 +3936,14 @@
       </p:sp>
       <p:sp>
         <p:nvSpPr>
-          <p:cNvPr id="12" name="TextBox 11"/>
+          <p:cNvPr id="13" name="TextBox 12"/>
           <p:cNvSpPr txBox="1"/>
           <p:nvPr/>
         </p:nvSpPr>
         <p:spPr>
           <a:xfrm>
-            <a:off x="1645920" y="3611880"/>
-            <a:ext cx="2743200" cy="457200"/>
+            <a:off x="1371600" y="3227832"/>
+            <a:ext cx="2286000" cy="365760"/>
           </a:xfrm>
           <a:prstGeom prst="rect">
             <a:avLst/>
@@ -3902,7 +3957,7 @@
           <a:lstStyle/>
           <a:p>
             <a:pPr algn="l">
-              <a:defRPr sz="1800" b="1">
+              <a:defRPr sz="1500" b="1">
                 <a:solidFill>
                   <a:srgbClr val="C084FC"/>
                 </a:solidFill>
@@ -3917,14 +3972,14 @@
       </p:sp>
       <p:sp>
         <p:nvSpPr>
-          <p:cNvPr id="13" name="TextBox 12"/>
+          <p:cNvPr id="14" name="TextBox 13"/>
           <p:cNvSpPr txBox="1"/>
           <p:nvPr/>
         </p:nvSpPr>
         <p:spPr>
           <a:xfrm>
-            <a:off x="4389120" y="3657600"/>
-            <a:ext cx="6858000" cy="457200"/>
+            <a:off x="1371600" y="3520440"/>
+            <a:ext cx="5852160" cy="320040"/>
           </a:xfrm>
           <a:prstGeom prst="rect">
             <a:avLst/>
@@ -3938,7 +3993,7 @@
           <a:lstStyle/>
           <a:p>
             <a:pPr algn="l">
-              <a:defRPr sz="1600" b="0">
+              <a:defRPr sz="1200" b="0">
                 <a:solidFill>
                   <a:srgbClr val="B3B3B3"/>
                 </a:solidFill>
@@ -3946,21 +4001,21 @@
               </a:defRPr>
             </a:pPr>
             <a:r>
-              <a:t>Traitements adaptes a chaque patient grace a l'IA</a:t>
-            </a:r>
-          </a:p>
-        </p:txBody>
-      </p:sp>
-      <p:sp>
-        <p:nvSpPr>
-          <p:cNvPr id="14" name="Rounded Rectangle 13"/>
+              <a:t>Traitements uniques pour chaque patient grace a l'analyse ADN par IA</a:t>
+            </a:r>
+          </a:p>
+        </p:txBody>
+      </p:sp>
+      <p:sp>
+        <p:nvSpPr>
+          <p:cNvPr id="15" name="Rounded Rectangle 14"/>
           <p:cNvSpPr/>
           <p:nvPr/>
         </p:nvSpPr>
         <p:spPr>
           <a:xfrm>
-            <a:off x="731520" y="4480560"/>
-            <a:ext cx="10698480" cy="822960"/>
+            <a:off x="548640" y="4023360"/>
+            <a:ext cx="6858000" cy="731520"/>
           </a:xfrm>
           <a:prstGeom prst="roundRect">
             <a:avLst>
@@ -3998,13 +4053,13 @@
       </p:sp>
       <p:sp>
         <p:nvSpPr>
-          <p:cNvPr id="15" name="Oval 14"/>
+          <p:cNvPr id="16" name="Oval 15"/>
           <p:cNvSpPr/>
           <p:nvPr/>
         </p:nvSpPr>
         <p:spPr>
           <a:xfrm>
-            <a:off x="1097280" y="4754880"/>
+            <a:off x="822960" y="4251960"/>
             <a:ext cx="274320" cy="274320"/>
           </a:xfrm>
           <a:prstGeom prst="ellipse">
@@ -4041,14 +4096,14 @@
       </p:sp>
       <p:sp>
         <p:nvSpPr>
-          <p:cNvPr id="16" name="TextBox 15"/>
+          <p:cNvPr id="17" name="TextBox 16"/>
           <p:cNvSpPr txBox="1"/>
           <p:nvPr/>
         </p:nvSpPr>
         <p:spPr>
           <a:xfrm>
-            <a:off x="1645920" y="4617720"/>
-            <a:ext cx="2743200" cy="457200"/>
+            <a:off x="1371600" y="4096512"/>
+            <a:ext cx="2286000" cy="365760"/>
           </a:xfrm>
           <a:prstGeom prst="rect">
             <a:avLst/>
@@ -4062,7 +4117,7 @@
           <a:lstStyle/>
           <a:p>
             <a:pPr algn="l">
-              <a:defRPr sz="1800" b="1">
+              <a:defRPr sz="1500" b="1">
                 <a:solidFill>
                   <a:srgbClr val="C084FC"/>
                 </a:solidFill>
@@ -4077,14 +4132,14 @@
       </p:sp>
       <p:sp>
         <p:nvSpPr>
-          <p:cNvPr id="17" name="TextBox 16"/>
+          <p:cNvPr id="18" name="TextBox 17"/>
           <p:cNvSpPr txBox="1"/>
           <p:nvPr/>
         </p:nvSpPr>
         <p:spPr>
           <a:xfrm>
-            <a:off x="4389120" y="4663440"/>
-            <a:ext cx="6858000" cy="457200"/>
+            <a:off x="1371600" y="4389120"/>
+            <a:ext cx="5852160" cy="320040"/>
           </a:xfrm>
           <a:prstGeom prst="rect">
             <a:avLst/>
@@ -4098,7 +4153,7 @@
           <a:lstStyle/>
           <a:p>
             <a:pPr algn="l">
-              <a:defRPr sz="1600" b="0">
+              <a:defRPr sz="1200" b="0">
                 <a:solidFill>
                   <a:srgbClr val="B3B3B3"/>
                 </a:solidFill>
@@ -4106,21 +4161,21 @@
               </a:defRPr>
             </a:pPr>
             <a:r>
-              <a:t>Des robots capables d'interagir naturellement avec les humains</a:t>
-            </a:r>
-          </a:p>
-        </p:txBody>
-      </p:sp>
-      <p:sp>
-        <p:nvSpPr>
-          <p:cNvPr id="18" name="Rounded Rectangle 17"/>
+              <a:t>Robots qui interagissent naturellement (Boston Dynamics, Tesla Optimus)</a:t>
+            </a:r>
+          </a:p>
+        </p:txBody>
+      </p:sp>
+      <p:sp>
+        <p:nvSpPr>
+          <p:cNvPr id="19" name="Rounded Rectangle 18"/>
           <p:cNvSpPr/>
           <p:nvPr/>
         </p:nvSpPr>
         <p:spPr>
           <a:xfrm>
-            <a:off x="731520" y="5486400"/>
-            <a:ext cx="10698480" cy="822960"/>
+            <a:off x="548640" y="4892040"/>
+            <a:ext cx="6858000" cy="731520"/>
           </a:xfrm>
           <a:prstGeom prst="roundRect">
             <a:avLst>
@@ -4158,13 +4213,13 @@
       </p:sp>
       <p:sp>
         <p:nvSpPr>
-          <p:cNvPr id="19" name="Oval 18"/>
+          <p:cNvPr id="20" name="Oval 19"/>
           <p:cNvSpPr/>
           <p:nvPr/>
         </p:nvSpPr>
         <p:spPr>
           <a:xfrm>
-            <a:off x="1097280" y="5760720"/>
+            <a:off x="822960" y="5120640"/>
             <a:ext cx="274320" cy="274320"/>
           </a:xfrm>
           <a:prstGeom prst="ellipse">
@@ -4201,14 +4256,14 @@
       </p:sp>
       <p:sp>
         <p:nvSpPr>
-          <p:cNvPr id="20" name="TextBox 19"/>
+          <p:cNvPr id="21" name="TextBox 20"/>
           <p:cNvSpPr txBox="1"/>
           <p:nvPr/>
         </p:nvSpPr>
         <p:spPr>
           <a:xfrm>
-            <a:off x="1645920" y="5623560"/>
-            <a:ext cx="2743200" cy="457200"/>
+            <a:off x="1371600" y="4965192"/>
+            <a:ext cx="2286000" cy="365760"/>
           </a:xfrm>
           <a:prstGeom prst="rect">
             <a:avLst/>
@@ -4222,7 +4277,7 @@
           <a:lstStyle/>
           <a:p>
             <a:pPr algn="l">
-              <a:defRPr sz="1800" b="1">
+              <a:defRPr sz="1500" b="1">
                 <a:solidFill>
                   <a:srgbClr val="C084FC"/>
                 </a:solidFill>
@@ -4237,14 +4292,14 @@
       </p:sp>
       <p:sp>
         <p:nvSpPr>
-          <p:cNvPr id="21" name="TextBox 20"/>
+          <p:cNvPr id="22" name="TextBox 21"/>
           <p:cNvSpPr txBox="1"/>
           <p:nvPr/>
         </p:nvSpPr>
         <p:spPr>
           <a:xfrm>
-            <a:off x="4389120" y="5669280"/>
-            <a:ext cx="6858000" cy="457200"/>
+            <a:off x="1371600" y="5257800"/>
+            <a:ext cx="5852160" cy="320040"/>
           </a:xfrm>
           <a:prstGeom prst="rect">
             <a:avLst/>
@@ -4258,7 +4313,7 @@
           <a:lstStyle/>
           <a:p>
             <a:pPr algn="l">
-              <a:defRPr sz="1600" b="0">
+              <a:defRPr sz="1200" b="0">
                 <a:solidFill>
                   <a:srgbClr val="B3B3B3"/>
                 </a:solidFill>
@@ -4266,7 +4321,167 @@
               </a:defRPr>
             </a:pPr>
             <a:r>
-              <a:t>Developpement de lois et reglementations pour encadrer l'IA</a:t>
+              <a:t>Nouvelles lois et reglementations pour encadrer l'utilisation de l'IA</a:t>
+            </a:r>
+          </a:p>
+        </p:txBody>
+      </p:sp>
+      <p:sp>
+        <p:nvSpPr>
+          <p:cNvPr id="23" name="Rounded Rectangle 22"/>
+          <p:cNvSpPr/>
+          <p:nvPr/>
+        </p:nvSpPr>
+        <p:spPr>
+          <a:xfrm>
+            <a:off x="548640" y="5760720"/>
+            <a:ext cx="6858000" cy="731520"/>
+          </a:xfrm>
+          <a:prstGeom prst="roundRect">
+            <a:avLst>
+              <a:gd name="adj" fmla="val 3000"/>
+            </a:avLst>
+          </a:prstGeom>
+          <a:solidFill>
+            <a:srgbClr val="1E1B4B"/>
+          </a:solidFill>
+          <a:ln>
+            <a:noFill/>
+          </a:ln>
+        </p:spPr>
+        <p:style>
+          <a:lnRef idx="1">
+            <a:schemeClr val="accent1"/>
+          </a:lnRef>
+          <a:fillRef idx="3">
+            <a:schemeClr val="accent1"/>
+          </a:fillRef>
+          <a:effectRef idx="2">
+            <a:schemeClr val="accent1"/>
+          </a:effectRef>
+          <a:fontRef idx="minor">
+            <a:schemeClr val="lt1"/>
+          </a:fontRef>
+        </p:style>
+        <p:txBody>
+          <a:bodyPr rtlCol="0" anchor="ctr"/>
+          <a:lstStyle/>
+          <a:p>
+            <a:pPr algn="ctr"/>
+          </a:p>
+        </p:txBody>
+      </p:sp>
+      <p:sp>
+        <p:nvSpPr>
+          <p:cNvPr id="24" name="Oval 23"/>
+          <p:cNvSpPr/>
+          <p:nvPr/>
+        </p:nvSpPr>
+        <p:spPr>
+          <a:xfrm>
+            <a:off x="822960" y="5989320"/>
+            <a:ext cx="274320" cy="274320"/>
+          </a:xfrm>
+          <a:prstGeom prst="ellipse">
+            <a:avLst/>
+          </a:prstGeom>
+          <a:solidFill>
+            <a:srgbClr val="F472B6"/>
+          </a:solidFill>
+          <a:ln>
+            <a:noFill/>
+          </a:ln>
+        </p:spPr>
+        <p:style>
+          <a:lnRef idx="1">
+            <a:schemeClr val="accent1"/>
+          </a:lnRef>
+          <a:fillRef idx="3">
+            <a:schemeClr val="accent1"/>
+          </a:fillRef>
+          <a:effectRef idx="2">
+            <a:schemeClr val="accent1"/>
+          </a:effectRef>
+          <a:fontRef idx="minor">
+            <a:schemeClr val="lt1"/>
+          </a:fontRef>
+        </p:style>
+        <p:txBody>
+          <a:bodyPr rtlCol="0" anchor="ctr"/>
+          <a:lstStyle/>
+          <a:p>
+            <a:pPr algn="ctr"/>
+          </a:p>
+        </p:txBody>
+      </p:sp>
+      <p:sp>
+        <p:nvSpPr>
+          <p:cNvPr id="25" name="TextBox 24"/>
+          <p:cNvSpPr txBox="1"/>
+          <p:nvPr/>
+        </p:nvSpPr>
+        <p:spPr>
+          <a:xfrm>
+            <a:off x="1371600" y="5833872"/>
+            <a:ext cx="2286000" cy="365760"/>
+          </a:xfrm>
+          <a:prstGeom prst="rect">
+            <a:avLst/>
+          </a:prstGeom>
+          <a:noFill/>
+        </p:spPr>
+        <p:txBody>
+          <a:bodyPr wrap="square">
+            <a:spAutoFit/>
+          </a:bodyPr>
+          <a:lstStyle/>
+          <a:p>
+            <a:pPr algn="l">
+              <a:defRPr sz="1500" b="1">
+                <a:solidFill>
+                  <a:srgbClr val="C084FC"/>
+                </a:solidFill>
+                <a:latin typeface="Calibri"/>
+              </a:defRPr>
+            </a:pPr>
+            <a:r>
+              <a:t>Education</a:t>
+            </a:r>
+          </a:p>
+        </p:txBody>
+      </p:sp>
+      <p:sp>
+        <p:nvSpPr>
+          <p:cNvPr id="26" name="TextBox 25"/>
+          <p:cNvSpPr txBox="1"/>
+          <p:nvPr/>
+        </p:nvSpPr>
+        <p:spPr>
+          <a:xfrm>
+            <a:off x="1371600" y="6126480"/>
+            <a:ext cx="5852160" cy="320040"/>
+          </a:xfrm>
+          <a:prstGeom prst="rect">
+            <a:avLst/>
+          </a:prstGeom>
+          <a:noFill/>
+        </p:spPr>
+        <p:txBody>
+          <a:bodyPr wrap="square">
+            <a:spAutoFit/>
+          </a:bodyPr>
+          <a:lstStyle/>
+          <a:p>
+            <a:pPr algn="l">
+              <a:defRPr sz="1200" b="0">
+                <a:solidFill>
+                  <a:srgbClr val="B3B3B3"/>
+                </a:solidFill>
+                <a:latin typeface="Calibri"/>
+              </a:defRPr>
+            </a:pPr>
+            <a:r>
+              <a:t>Professeurs IA personnels, adaptation au niveau de chaque eleve</a:t>
             </a:r>
           </a:p>
         </p:txBody>
@@ -4407,11 +4622,7 @@
               </a:defRPr>
             </a:pPr>
             <a:r>
-              <a:t>L'IA : Un Outil Puissant a Utiliser</a:t>
-            </a:r>
-            <a:br/>
-            <a:r>
-              <a:t>avec Responsabilite</a:t>
+              <a:t>L'IA : Un Outil Puissant a Utiliser avec Responsabilite</a:t>
             </a:r>
           </a:p>
         </p:txBody>
@@ -4424,8 +4635,8 @@
         </p:nvSpPr>
         <p:spPr>
           <a:xfrm>
-            <a:off x="1828800" y="2286000"/>
-            <a:ext cx="8503920" cy="1097280"/>
+            <a:off x="1371600" y="2286000"/>
+            <a:ext cx="9418320" cy="1097280"/>
           </a:xfrm>
           <a:prstGeom prst="rect">
             <a:avLst/>
@@ -4447,7 +4658,7 @@
               </a:defRPr>
             </a:pPr>
             <a:r>
-              <a:t>L'intelligence artificielle est l'une des technologies les plus transformatrices de notre epoque. Elle offre des possibilites enormes pour ameliorer notre vie, mais elle souleve aussi des defis importants.</a:t>
+              <a:t>L'intelligence artificielle transforme notre monde. Elle offre des possibilites immenses pour la medecine, l'education, l'environnement et bien plus. Mais elle souleve aussi des defis importants : vie privee, emploi, ethique.</a:t>
             </a:r>
           </a:p>
         </p:txBody>
@@ -4460,8 +4671,8 @@
         </p:nvSpPr>
         <p:spPr>
           <a:xfrm>
-            <a:off x="1828800" y="3474720"/>
-            <a:ext cx="8503920" cy="1097280"/>
+            <a:off x="1371600" y="3474720"/>
+            <a:ext cx="9418320" cy="914400"/>
           </a:xfrm>
           <a:prstGeom prst="rect">
             <a:avLst/>
@@ -4483,7 +4694,7 @@
               </a:defRPr>
             </a:pPr>
             <a:r>
-              <a:t>En tant qu'etudiants et futurs citoyens, il est essentiel de comprendre comment l'IA fonctionne, de connaitre ses avantages et ses limites, et de contribuer a son developpement de maniere ethique et responsable.</a:t>
+              <a:t>En tant qu'etudiants et futurs citoyens, nous devons comprendre l'IA, connaitre ses avantages et ses limites, et contribuer a un developpement ethique et responsable de cette technologie.</a:t>
             </a:r>
           </a:p>
         </p:txBody>
@@ -4496,8 +4707,8 @@
         </p:nvSpPr>
         <p:spPr>
           <a:xfrm>
-            <a:off x="2743200" y="4846320"/>
-            <a:ext cx="6675120" cy="1371600"/>
+            <a:off x="2286000" y="4754880"/>
+            <a:ext cx="7589520" cy="1371600"/>
           </a:xfrm>
           <a:prstGeom prst="roundRect">
             <a:avLst>
@@ -4541,8 +4752,8 @@
         </p:nvSpPr>
         <p:spPr>
           <a:xfrm>
-            <a:off x="3017520" y="5029200"/>
-            <a:ext cx="6126480" cy="640080"/>
+            <a:off x="2560320" y="4937760"/>
+            <a:ext cx="7040880" cy="640080"/>
           </a:xfrm>
           <a:prstGeom prst="rect">
             <a:avLst/>
@@ -4556,7 +4767,7 @@
           <a:lstStyle/>
           <a:p>
             <a:pPr algn="ctr">
-              <a:defRPr sz="2000" b="1">
+              <a:defRPr sz="2200" b="1">
                 <a:solidFill>
                   <a:srgbClr val="C084FC"/>
                 </a:solidFill>
@@ -4577,8 +4788,8 @@
         </p:nvSpPr>
         <p:spPr>
           <a:xfrm>
-            <a:off x="3017520" y="5669280"/>
-            <a:ext cx="6126480" cy="365760"/>
+            <a:off x="2560320" y="5577840"/>
+            <a:ext cx="7040880" cy="365760"/>
           </a:xfrm>
           <a:prstGeom prst="rect">
             <a:avLst/>
@@ -4600,7 +4811,7 @@
               </a:defRPr>
             </a:pPr>
             <a:r>
-              <a:t>- Andrew Ng, expert en IA</a:t>
+              <a:t>- Andrew Ng, professeur a Stanford et expert mondial en IA</a:t>
             </a:r>
           </a:p>
         </p:txBody>
@@ -4777,7 +4988,7 @@
               </a:defRPr>
             </a:pPr>
             <a:r>
-              <a:t>Tronc Commun Scientifique</a:t>
+              <a:t>Tronc Commun Scientifique - 2024/2025</a:t>
             </a:r>
           </a:p>
         </p:txBody>
@@ -5047,7 +5258,7 @@
           </a:fontRef>
         </p:style>
         <p:txBody>
-          <a:bodyPr rtlCol="0" anchor="ctr" wrap="none"/>
+          <a:bodyPr rtlCol="0" anchor="ctr"/>
           <a:lstStyle/>
           <a:p>
             <a:pPr algn="ctr">
@@ -5094,7 +5305,7 @@
               </a:defRPr>
             </a:pPr>
             <a:r>
-              <a:t> Qu'est-ce que l'IA ?</a:t>
+              <a:t>Qu'est-ce que l'IA ?</a:t>
             </a:r>
           </a:p>
         </p:txBody>
@@ -5180,7 +5391,7 @@
           </a:fontRef>
         </p:style>
         <p:txBody>
-          <a:bodyPr rtlCol="0" anchor="ctr" wrap="none"/>
+          <a:bodyPr rtlCol="0" anchor="ctr"/>
           <a:lstStyle/>
           <a:p>
             <a:pPr algn="ctr">
@@ -5227,7 +5438,7 @@
               </a:defRPr>
             </a:pPr>
             <a:r>
-              <a:t> Histoire de l'IA</a:t>
+              <a:t>Histoire de l'IA</a:t>
             </a:r>
           </a:p>
         </p:txBody>
@@ -5313,7 +5524,7 @@
           </a:fontRef>
         </p:style>
         <p:txBody>
-          <a:bodyPr rtlCol="0" anchor="ctr" wrap="none"/>
+          <a:bodyPr rtlCol="0" anchor="ctr"/>
           <a:lstStyle/>
           <a:p>
             <a:pPr algn="ctr">
@@ -5360,7 +5571,7 @@
               </a:defRPr>
             </a:pPr>
             <a:r>
-              <a:t> Les types d'IA</a:t>
+              <a:t>Les types d'IA</a:t>
             </a:r>
           </a:p>
         </p:txBody>
@@ -5446,7 +5657,7 @@
           </a:fontRef>
         </p:style>
         <p:txBody>
-          <a:bodyPr rtlCol="0" anchor="ctr" wrap="none"/>
+          <a:bodyPr rtlCol="0" anchor="ctr"/>
           <a:lstStyle/>
           <a:p>
             <a:pPr algn="ctr">
@@ -5493,7 +5704,7 @@
               </a:defRPr>
             </a:pPr>
             <a:r>
-              <a:t> Comment fonctionne l'IA ?</a:t>
+              <a:t>Comment fonctionne l'IA ?</a:t>
             </a:r>
           </a:p>
         </p:txBody>
@@ -5579,7 +5790,7 @@
           </a:fontRef>
         </p:style>
         <p:txBody>
-          <a:bodyPr rtlCol="0" anchor="ctr" wrap="none"/>
+          <a:bodyPr rtlCol="0" anchor="ctr"/>
           <a:lstStyle/>
           <a:p>
             <a:pPr algn="ctr">
@@ -5626,7 +5837,7 @@
               </a:defRPr>
             </a:pPr>
             <a:r>
-              <a:t> Applications de l'IA</a:t>
+              <a:t>Applications de l'IA</a:t>
             </a:r>
           </a:p>
         </p:txBody>
@@ -5712,7 +5923,7 @@
           </a:fontRef>
         </p:style>
         <p:txBody>
-          <a:bodyPr rtlCol="0" anchor="ctr" wrap="none"/>
+          <a:bodyPr rtlCol="0" anchor="ctr"/>
           <a:lstStyle/>
           <a:p>
             <a:pPr algn="ctr">
@@ -5759,7 +5970,7 @@
               </a:defRPr>
             </a:pPr>
             <a:r>
-              <a:t> L'IA dans la vie quotidienne</a:t>
+              <a:t>L'IA dans la vie quotidienne</a:t>
             </a:r>
           </a:p>
         </p:txBody>
@@ -5845,7 +6056,7 @@
           </a:fontRef>
         </p:style>
         <p:txBody>
-          <a:bodyPr rtlCol="0" anchor="ctr" wrap="none"/>
+          <a:bodyPr rtlCol="0" anchor="ctr"/>
           <a:lstStyle/>
           <a:p>
             <a:pPr algn="ctr">
@@ -5892,7 +6103,7 @@
               </a:defRPr>
             </a:pPr>
             <a:r>
-              <a:t> Avantages et Inconvenients</a:t>
+              <a:t>Avantages et Inconvenients</a:t>
             </a:r>
           </a:p>
         </p:txBody>
@@ -5978,7 +6189,7 @@
           </a:fontRef>
         </p:style>
         <p:txBody>
-          <a:bodyPr rtlCol="0" anchor="ctr" wrap="none"/>
+          <a:bodyPr rtlCol="0" anchor="ctr"/>
           <a:lstStyle/>
           <a:p>
             <a:pPr algn="ctr">
@@ -6025,7 +6236,7 @@
               </a:defRPr>
             </a:pPr>
             <a:r>
-              <a:t> L'avenir de l'IA</a:t>
+              <a:t>L'avenir de l'IA</a:t>
             </a:r>
           </a:p>
         </p:txBody>
@@ -6180,7 +6391,7 @@
         <p:spPr>
           <a:xfrm>
             <a:off x="731520" y="1828800"/>
-            <a:ext cx="6400800" cy="4114800"/>
+            <a:ext cx="5943600" cy="4114800"/>
           </a:xfrm>
           <a:prstGeom prst="rect">
             <a:avLst/>
@@ -6195,9 +6406,9 @@
           <a:p>
             <a:pPr>
               <a:spcAft>
-                <a:spcPts val="1400"/>
+                <a:spcPts val="1200"/>
               </a:spcAft>
-              <a:defRPr sz="1700">
+              <a:defRPr sz="1600">
                 <a:solidFill>
                   <a:srgbClr val="B3B3B3"/>
                 </a:solidFill>
@@ -6216,7 +6427,7 @@
               <a:spcAft>
                 <a:spcPts val="600"/>
               </a:spcAft>
-              <a:defRPr sz="1700" b="0">
+              <a:defRPr sz="1600" b="0">
                 <a:solidFill>
                   <a:srgbClr val="B3B3B3"/>
                 </a:solidFill>
@@ -6224,8 +6435,119 @@
               </a:defRPr>
             </a:pPr>
             <a:r>
-              <a:t>Ces taches incluent : la reconnaissance vocale, la prise de decision, la traduction de langues, et la perception visuelle.</a:t>
-            </a:r>
+              <a:t>Ces taches incluent :</a:t>
+            </a:r>
+          </a:p>
+          <a:p>
+            <a:pPr algn="l">
+              <a:spcBef>
+                <a:spcPts val="200"/>
+              </a:spcBef>
+              <a:spcAft>
+                <a:spcPts val="200"/>
+              </a:spcAft>
+              <a:defRPr sz="1400" b="0">
+                <a:solidFill>
+                  <a:srgbClr val="B3B3B3"/>
+                </a:solidFill>
+                <a:latin typeface="Calibri"/>
+              </a:defRPr>
+            </a:pPr>
+            <a:r>
+              <a:t>  *  La reconnaissance vocale et d'images</a:t>
+            </a:r>
+          </a:p>
+          <a:p>
+            <a:pPr algn="l">
+              <a:spcBef>
+                <a:spcPts val="200"/>
+              </a:spcBef>
+              <a:spcAft>
+                <a:spcPts val="200"/>
+              </a:spcAft>
+              <a:defRPr sz="1400" b="0">
+                <a:solidFill>
+                  <a:srgbClr val="B3B3B3"/>
+                </a:solidFill>
+                <a:latin typeface="Calibri"/>
+              </a:defRPr>
+            </a:pPr>
+            <a:r>
+              <a:t>  *  La prise de decision autonome</a:t>
+            </a:r>
+          </a:p>
+          <a:p>
+            <a:pPr algn="l">
+              <a:spcBef>
+                <a:spcPts val="200"/>
+              </a:spcBef>
+              <a:spcAft>
+                <a:spcPts val="200"/>
+              </a:spcAft>
+              <a:defRPr sz="1400" b="0">
+                <a:solidFill>
+                  <a:srgbClr val="B3B3B3"/>
+                </a:solidFill>
+                <a:latin typeface="Calibri"/>
+              </a:defRPr>
+            </a:pPr>
+            <a:r>
+              <a:t>  *  La traduction de langues</a:t>
+            </a:r>
+          </a:p>
+          <a:p>
+            <a:pPr algn="l">
+              <a:spcBef>
+                <a:spcPts val="200"/>
+              </a:spcBef>
+              <a:spcAft>
+                <a:spcPts val="200"/>
+              </a:spcAft>
+              <a:defRPr sz="1400" b="0">
+                <a:solidFill>
+                  <a:srgbClr val="B3B3B3"/>
+                </a:solidFill>
+                <a:latin typeface="Calibri"/>
+              </a:defRPr>
+            </a:pPr>
+            <a:r>
+              <a:t>  *  La perception visuelle</a:t>
+            </a:r>
+          </a:p>
+          <a:p>
+            <a:pPr algn="l">
+              <a:spcBef>
+                <a:spcPts val="200"/>
+              </a:spcBef>
+              <a:spcAft>
+                <a:spcPts val="200"/>
+              </a:spcAft>
+              <a:defRPr sz="1400" b="0">
+                <a:solidFill>
+                  <a:srgbClr val="B3B3B3"/>
+                </a:solidFill>
+                <a:latin typeface="Calibri"/>
+              </a:defRPr>
+            </a:pPr>
+            <a:r>
+              <a:t>  *  L'apprentissage a partir de donnees</a:t>
+            </a:r>
+          </a:p>
+          <a:p>
+            <a:pPr algn="l">
+              <a:spcBef>
+                <a:spcPts val="400"/>
+              </a:spcBef>
+              <a:spcAft>
+                <a:spcPts val="400"/>
+              </a:spcAft>
+              <a:defRPr sz="800" b="0">
+                <a:solidFill>
+                  <a:srgbClr val="B3B3B3"/>
+                </a:solidFill>
+                <a:latin typeface="Calibri"/>
+              </a:defRPr>
+            </a:pPr>
           </a:p>
           <a:p>
             <a:pPr algn="l">
@@ -6235,155 +6557,43 @@
               <a:spcAft>
                 <a:spcPts val="600"/>
               </a:spcAft>
-              <a:defRPr sz="1700" b="0">
-                <a:solidFill>
-                  <a:srgbClr val="B3B3B3"/>
-                </a:solidFill>
-                <a:latin typeface="Calibri"/>
-              </a:defRPr>
-            </a:pPr>
-            <a:r>
-              <a:t>Le terme "Intelligence Artificielle" a ete invente par John McCarthy en 1956 lors de la conference de Dartmouth.</a:t>
-            </a:r>
-          </a:p>
-          <a:p>
-            <a:pPr algn="l">
-              <a:spcBef>
-                <a:spcPts val="600"/>
-              </a:spcBef>
-              <a:spcAft>
-                <a:spcPts val="600"/>
-              </a:spcAft>
-              <a:defRPr sz="1700" b="0">
-                <a:solidFill>
-                  <a:srgbClr val="B3B3B3"/>
-                </a:solidFill>
-                <a:latin typeface="Calibri"/>
-              </a:defRPr>
-            </a:pPr>
-            <a:r>
-              <a:t>L'IA cherche a simuler les processus cognitifs humains comme l'apprentissage, le raisonnement, et l'auto-correction.</a:t>
-            </a:r>
-          </a:p>
-        </p:txBody>
-      </p:sp>
-      <p:sp>
-        <p:nvSpPr>
-          <p:cNvPr id="6" name="Rounded Rectangle 5"/>
-          <p:cNvSpPr/>
-          <p:nvPr/>
-        </p:nvSpPr>
-        <p:spPr>
-          <a:xfrm>
-            <a:off x="7772400" y="2011680"/>
-            <a:ext cx="3657600" cy="3657600"/>
-          </a:xfrm>
-          <a:prstGeom prst="roundRect">
-            <a:avLst>
-              <a:gd name="adj" fmla="val 5000"/>
-            </a:avLst>
-          </a:prstGeom>
-          <a:solidFill>
-            <a:srgbClr val="1E1B4B"/>
-          </a:solidFill>
-          <a:ln>
-            <a:noFill/>
-          </a:ln>
-        </p:spPr>
-        <p:style>
-          <a:lnRef idx="1">
-            <a:schemeClr val="accent1"/>
-          </a:lnRef>
-          <a:fillRef idx="3">
-            <a:schemeClr val="accent1"/>
-          </a:fillRef>
-          <a:effectRef idx="2">
-            <a:schemeClr val="accent1"/>
-          </a:effectRef>
-          <a:fontRef idx="minor">
-            <a:schemeClr val="lt1"/>
-          </a:fontRef>
-        </p:style>
-        <p:txBody>
-          <a:bodyPr rtlCol="0" anchor="ctr"/>
-          <a:lstStyle/>
-          <a:p>
-            <a:pPr algn="ctr"/>
-          </a:p>
-        </p:txBody>
-      </p:sp>
-      <p:sp>
-        <p:nvSpPr>
-          <p:cNvPr id="7" name="TextBox 6"/>
-          <p:cNvSpPr txBox="1"/>
-          <p:nvPr/>
-        </p:nvSpPr>
-        <p:spPr>
-          <a:xfrm>
-            <a:off x="7772400" y="2743200"/>
-            <a:ext cx="3657600" cy="1371600"/>
-          </a:xfrm>
-          <a:prstGeom prst="rect">
-            <a:avLst/>
-          </a:prstGeom>
-          <a:noFill/>
-        </p:spPr>
-        <p:txBody>
-          <a:bodyPr wrap="square">
-            <a:spAutoFit/>
-          </a:bodyPr>
-          <a:lstStyle/>
-          <a:p>
-            <a:pPr algn="ctr">
-              <a:defRPr sz="8000" b="1">
-                <a:solidFill>
-                  <a:srgbClr val="818CF8"/>
-                </a:solidFill>
-                <a:latin typeface="Calibri"/>
-              </a:defRPr>
-            </a:pPr>
-            <a:r>
-              <a:t>IA</a:t>
-            </a:r>
-          </a:p>
-        </p:txBody>
-      </p:sp>
-      <p:sp>
-        <p:nvSpPr>
-          <p:cNvPr id="8" name="TextBox 7"/>
-          <p:cNvSpPr txBox="1"/>
-          <p:nvPr/>
-        </p:nvSpPr>
-        <p:spPr>
-          <a:xfrm>
-            <a:off x="7772400" y="4114800"/>
-            <a:ext cx="3657600" cy="457200"/>
-          </a:xfrm>
-          <a:prstGeom prst="rect">
-            <a:avLst/>
-          </a:prstGeom>
-          <a:noFill/>
-        </p:spPr>
-        <p:txBody>
-          <a:bodyPr wrap="square">
-            <a:spAutoFit/>
-          </a:bodyPr>
-          <a:lstStyle/>
-          <a:p>
-            <a:pPr algn="ctr">
-              <a:defRPr sz="1400" b="0">
-                <a:solidFill>
-                  <a:srgbClr val="808080"/>
-                </a:solidFill>
-                <a:latin typeface="Calibri"/>
-              </a:defRPr>
-            </a:pPr>
-            <a:r>
-              <a:t>Intelligence Artificielle</a:t>
-            </a:r>
-          </a:p>
-        </p:txBody>
-      </p:sp>
+              <a:defRPr sz="1600" b="1">
+                <a:solidFill>
+                  <a:srgbClr val="C084FC"/>
+                </a:solidFill>
+                <a:latin typeface="Calibri"/>
+              </a:defRPr>
+            </a:pPr>
+            <a:r>
+              <a:t>Le terme "Intelligence Artificielle" a ete invente par John McCarthy en 1956.</a:t>
+            </a:r>
+          </a:p>
+        </p:txBody>
+      </p:sp>
+      <p:pic>
+        <p:nvPicPr>
+          <p:cNvPr id="6" name="Picture 5" descr="ai-robot.jpg"/>
+          <p:cNvPicPr>
+            <a:picLocks noChangeAspect="1"/>
+          </p:cNvPicPr>
+          <p:nvPr/>
+        </p:nvPicPr>
+        <p:blipFill>
+          <a:blip r:embed="rId2"/>
+          <a:stretch>
+            <a:fillRect/>
+          </a:stretch>
+        </p:blipFill>
+        <p:spPr>
+          <a:xfrm>
+            <a:off x="7315200" y="1828800"/>
+            <a:ext cx="4389120" cy="2926080"/>
+          </a:xfrm>
+          <a:prstGeom prst="rect">
+            <a:avLst/>
+          </a:prstGeom>
+        </p:spPr>
+      </p:pic>
     </p:spTree>
   </p:cSld>
   <p:clrMapOvr>
@@ -6525,9 +6735,33 @@
           </a:p>
         </p:txBody>
       </p:sp>
-      <p:sp>
-        <p:nvSpPr>
-          <p:cNvPr id="5" name="Rounded Rectangle 4"/>
+      <p:pic>
+        <p:nvPicPr>
+          <p:cNvPr id="5" name="Picture 4" descr="ai-chess.jpg"/>
+          <p:cNvPicPr>
+            <a:picLocks noChangeAspect="1"/>
+          </p:cNvPicPr>
+          <p:nvPr/>
+        </p:nvPicPr>
+        <p:blipFill>
+          <a:blip r:embed="rId2"/>
+          <a:stretch>
+            <a:fillRect/>
+          </a:stretch>
+        </p:blipFill>
+        <p:spPr>
+          <a:xfrm>
+            <a:off x="8046720" y="1828800"/>
+            <a:ext cx="3657600" cy="2438400"/>
+          </a:xfrm>
+          <a:prstGeom prst="rect">
+            <a:avLst/>
+          </a:prstGeom>
+        </p:spPr>
+      </p:pic>
+      <p:sp>
+        <p:nvSpPr>
+          <p:cNvPr id="6" name="Rounded Rectangle 5"/>
           <p:cNvSpPr/>
           <p:nvPr/>
         </p:nvSpPr>
@@ -6570,7 +6804,7 @@
       </p:sp>
       <p:sp>
         <p:nvSpPr>
-          <p:cNvPr id="6" name="Oval 5"/>
+          <p:cNvPr id="7" name="Oval 6"/>
           <p:cNvSpPr/>
           <p:nvPr/>
         </p:nvSpPr>
@@ -6613,7 +6847,7 @@
       </p:sp>
       <p:sp>
         <p:nvSpPr>
-          <p:cNvPr id="7" name="TextBox 6"/>
+          <p:cNvPr id="8" name="TextBox 7"/>
           <p:cNvSpPr txBox="1"/>
           <p:nvPr/>
         </p:nvSpPr>
@@ -6649,14 +6883,14 @@
       </p:sp>
       <p:sp>
         <p:nvSpPr>
-          <p:cNvPr id="8" name="TextBox 7"/>
+          <p:cNvPr id="9" name="TextBox 8"/>
           <p:cNvSpPr txBox="1"/>
           <p:nvPr/>
         </p:nvSpPr>
         <p:spPr>
           <a:xfrm>
             <a:off x="3017520" y="1719072"/>
-            <a:ext cx="8229600" cy="365760"/>
+            <a:ext cx="4754880" cy="365760"/>
           </a:xfrm>
           <a:prstGeom prst="rect">
             <a:avLst/>
@@ -6678,14 +6912,14 @@
               </a:defRPr>
             </a:pPr>
             <a:r>
-              <a:t>Alan Turing propose le 'Test de Turing' pour mesurer l'intelligence des machines</a:t>
-            </a:r>
-          </a:p>
-        </p:txBody>
-      </p:sp>
-      <p:sp>
-        <p:nvSpPr>
-          <p:cNvPr id="9" name="Oval 8"/>
+              <a:t>Alan Turing propose le 'Test de Turing'</a:t>
+            </a:r>
+          </a:p>
+        </p:txBody>
+      </p:sp>
+      <p:sp>
+        <p:nvSpPr>
+          <p:cNvPr id="10" name="Oval 9"/>
           <p:cNvSpPr/>
           <p:nvPr/>
         </p:nvSpPr>
@@ -6728,7 +6962,7 @@
       </p:sp>
       <p:sp>
         <p:nvSpPr>
-          <p:cNvPr id="10" name="TextBox 9"/>
+          <p:cNvPr id="11" name="TextBox 10"/>
           <p:cNvSpPr txBox="1"/>
           <p:nvPr/>
         </p:nvSpPr>
@@ -6764,14 +6998,14 @@
       </p:sp>
       <p:sp>
         <p:nvSpPr>
-          <p:cNvPr id="11" name="TextBox 10"/>
+          <p:cNvPr id="12" name="TextBox 11"/>
           <p:cNvSpPr txBox="1"/>
           <p:nvPr/>
         </p:nvSpPr>
         <p:spPr>
           <a:xfrm>
             <a:off x="3017520" y="2395728"/>
-            <a:ext cx="8229600" cy="365760"/>
+            <a:ext cx="4754880" cy="365760"/>
           </a:xfrm>
           <a:prstGeom prst="rect">
             <a:avLst/>
@@ -6793,14 +7027,14 @@
               </a:defRPr>
             </a:pPr>
             <a:r>
-              <a:t>Conference de Dartmouth : naissance officielle de l'IA comme domaine de recherche</a:t>
-            </a:r>
-          </a:p>
-        </p:txBody>
-      </p:sp>
-      <p:sp>
-        <p:nvSpPr>
-          <p:cNvPr id="12" name="Oval 11"/>
+              <a:t>Conference de Dartmouth : naissance de l'IA</a:t>
+            </a:r>
+          </a:p>
+        </p:txBody>
+      </p:sp>
+      <p:sp>
+        <p:nvSpPr>
+          <p:cNvPr id="13" name="Oval 12"/>
           <p:cNvSpPr/>
           <p:nvPr/>
         </p:nvSpPr>
@@ -6843,7 +7077,7 @@
       </p:sp>
       <p:sp>
         <p:nvSpPr>
-          <p:cNvPr id="13" name="TextBox 12"/>
+          <p:cNvPr id="14" name="TextBox 13"/>
           <p:cNvSpPr txBox="1"/>
           <p:nvPr/>
         </p:nvSpPr>
@@ -6879,14 +7113,14 @@
       </p:sp>
       <p:sp>
         <p:nvSpPr>
-          <p:cNvPr id="14" name="TextBox 13"/>
+          <p:cNvPr id="15" name="TextBox 14"/>
           <p:cNvSpPr txBox="1"/>
           <p:nvPr/>
         </p:nvSpPr>
         <p:spPr>
           <a:xfrm>
             <a:off x="3017520" y="3072384"/>
-            <a:ext cx="8229600" cy="365760"/>
+            <a:ext cx="4754880" cy="365760"/>
           </a:xfrm>
           <a:prstGeom prst="rect">
             <a:avLst/>
@@ -6908,14 +7142,14 @@
               </a:defRPr>
             </a:pPr>
             <a:r>
-              <a:t>ELIZA, le premier chatbot, est cree par Joseph Weizenbaum au MIT</a:t>
-            </a:r>
-          </a:p>
-        </p:txBody>
-      </p:sp>
-      <p:sp>
-        <p:nvSpPr>
-          <p:cNvPr id="15" name="Oval 14"/>
+              <a:t>ELIZA, le premier chatbot (MIT)</a:t>
+            </a:r>
+          </a:p>
+        </p:txBody>
+      </p:sp>
+      <p:sp>
+        <p:nvSpPr>
+          <p:cNvPr id="16" name="Oval 15"/>
           <p:cNvSpPr/>
           <p:nvPr/>
         </p:nvSpPr>
@@ -6958,7 +7192,7 @@
       </p:sp>
       <p:sp>
         <p:nvSpPr>
-          <p:cNvPr id="16" name="TextBox 15"/>
+          <p:cNvPr id="17" name="TextBox 16"/>
           <p:cNvSpPr txBox="1"/>
           <p:nvPr/>
         </p:nvSpPr>
@@ -6994,14 +7228,14 @@
       </p:sp>
       <p:sp>
         <p:nvSpPr>
-          <p:cNvPr id="17" name="TextBox 16"/>
+          <p:cNvPr id="18" name="TextBox 17"/>
           <p:cNvSpPr txBox="1"/>
           <p:nvPr/>
         </p:nvSpPr>
         <p:spPr>
           <a:xfrm>
             <a:off x="3017520" y="3749040"/>
-            <a:ext cx="8229600" cy="365760"/>
+            <a:ext cx="4754880" cy="365760"/>
           </a:xfrm>
           <a:prstGeom prst="rect">
             <a:avLst/>
@@ -7023,14 +7257,14 @@
               </a:defRPr>
             </a:pPr>
             <a:r>
-              <a:t>Deep Blue (IBM) bat le champion du monde d'echecs Garry Kasparov</a:t>
-            </a:r>
-          </a:p>
-        </p:txBody>
-      </p:sp>
-      <p:sp>
-        <p:nvSpPr>
-          <p:cNvPr id="18" name="Oval 17"/>
+              <a:t>Deep Blue bat Garry Kasparov aux echecs</a:t>
+            </a:r>
+          </a:p>
+        </p:txBody>
+      </p:sp>
+      <p:sp>
+        <p:nvSpPr>
+          <p:cNvPr id="19" name="Oval 18"/>
           <p:cNvSpPr/>
           <p:nvPr/>
         </p:nvSpPr>
@@ -7073,7 +7307,7 @@
       </p:sp>
       <p:sp>
         <p:nvSpPr>
-          <p:cNvPr id="19" name="TextBox 18"/>
+          <p:cNvPr id="20" name="TextBox 19"/>
           <p:cNvSpPr txBox="1"/>
           <p:nvPr/>
         </p:nvSpPr>
@@ -7109,14 +7343,14 @@
       </p:sp>
       <p:sp>
         <p:nvSpPr>
-          <p:cNvPr id="20" name="TextBox 19"/>
+          <p:cNvPr id="21" name="TextBox 20"/>
           <p:cNvSpPr txBox="1"/>
           <p:nvPr/>
         </p:nvSpPr>
         <p:spPr>
           <a:xfrm>
             <a:off x="3017520" y="4425696"/>
-            <a:ext cx="8229600" cy="365760"/>
+            <a:ext cx="4754880" cy="365760"/>
           </a:xfrm>
           <a:prstGeom prst="rect">
             <a:avLst/>
@@ -7138,14 +7372,14 @@
               </a:defRPr>
             </a:pPr>
             <a:r>
-              <a:t>IBM Watson gagne au jeu televise Jeopardy! contre des champions humains</a:t>
-            </a:r>
-          </a:p>
-        </p:txBody>
-      </p:sp>
-      <p:sp>
-        <p:nvSpPr>
-          <p:cNvPr id="21" name="Oval 20"/>
+              <a:t>IBM Watson gagne a Jeopardy!</a:t>
+            </a:r>
+          </a:p>
+        </p:txBody>
+      </p:sp>
+      <p:sp>
+        <p:nvSpPr>
+          <p:cNvPr id="22" name="Oval 21"/>
           <p:cNvSpPr/>
           <p:nvPr/>
         </p:nvSpPr>
@@ -7188,7 +7422,7 @@
       </p:sp>
       <p:sp>
         <p:nvSpPr>
-          <p:cNvPr id="22" name="TextBox 21"/>
+          <p:cNvPr id="23" name="TextBox 22"/>
           <p:cNvSpPr txBox="1"/>
           <p:nvPr/>
         </p:nvSpPr>
@@ -7224,14 +7458,14 @@
       </p:sp>
       <p:sp>
         <p:nvSpPr>
-          <p:cNvPr id="23" name="TextBox 22"/>
+          <p:cNvPr id="24" name="TextBox 23"/>
           <p:cNvSpPr txBox="1"/>
           <p:nvPr/>
         </p:nvSpPr>
         <p:spPr>
           <a:xfrm>
             <a:off x="3017520" y="5102352"/>
-            <a:ext cx="8229600" cy="365760"/>
+            <a:ext cx="4754880" cy="365760"/>
           </a:xfrm>
           <a:prstGeom prst="rect">
             <a:avLst/>
@@ -7253,14 +7487,14 @@
               </a:defRPr>
             </a:pPr>
             <a:r>
-              <a:t>AlphaGo (Google DeepMind) bat le champion mondial du jeu de Go</a:t>
-            </a:r>
-          </a:p>
-        </p:txBody>
-      </p:sp>
-      <p:sp>
-        <p:nvSpPr>
-          <p:cNvPr id="24" name="Oval 23"/>
+              <a:t>AlphaGo bat le champion mondial de Go</a:t>
+            </a:r>
+          </a:p>
+        </p:txBody>
+      </p:sp>
+      <p:sp>
+        <p:nvSpPr>
+          <p:cNvPr id="25" name="Oval 24"/>
           <p:cNvSpPr/>
           <p:nvPr/>
         </p:nvSpPr>
@@ -7303,7 +7537,7 @@
       </p:sp>
       <p:sp>
         <p:nvSpPr>
-          <p:cNvPr id="25" name="TextBox 24"/>
+          <p:cNvPr id="26" name="TextBox 25"/>
           <p:cNvSpPr txBox="1"/>
           <p:nvPr/>
         </p:nvSpPr>
@@ -7332,21 +7566,21 @@
               </a:defRPr>
             </a:pPr>
             <a:r>
-              <a:t>2022+</a:t>
-            </a:r>
-          </a:p>
-        </p:txBody>
-      </p:sp>
-      <p:sp>
-        <p:nvSpPr>
-          <p:cNvPr id="26" name="TextBox 25"/>
+              <a:t>2022</a:t>
+            </a:r>
+          </a:p>
+        </p:txBody>
+      </p:sp>
+      <p:sp>
+        <p:nvSpPr>
+          <p:cNvPr id="27" name="TextBox 26"/>
           <p:cNvSpPr txBox="1"/>
           <p:nvPr/>
         </p:nvSpPr>
         <p:spPr>
           <a:xfrm>
             <a:off x="3017520" y="5779008"/>
-            <a:ext cx="8229600" cy="365760"/>
+            <a:ext cx="4754880" cy="365760"/>
           </a:xfrm>
           <a:prstGeom prst="rect">
             <a:avLst/>
@@ -7368,7 +7602,7 @@
               </a:defRPr>
             </a:pPr>
             <a:r>
-              <a:t>ChatGPT et les grands modeles de langage revolutionnent l'IA generative</a:t>
+              <a:t>ChatGPT revolutionne l'IA generative</a:t>
             </a:r>
           </a:p>
         </p:txBody>
@@ -7522,8 +7756,8 @@
         </p:nvSpPr>
         <p:spPr>
           <a:xfrm>
-            <a:off x="548640" y="1828800"/>
-            <a:ext cx="3566160" cy="4389120"/>
+            <a:off x="457200" y="1828800"/>
+            <a:ext cx="3566160" cy="4572000"/>
           </a:xfrm>
           <a:prstGeom prst="roundRect">
             <a:avLst>
@@ -7567,8 +7801,8 @@
         </p:nvSpPr>
         <p:spPr>
           <a:xfrm>
-            <a:off x="1645920" y="2103120"/>
-            <a:ext cx="1371600" cy="1371600"/>
+            <a:off x="731520" y="2103120"/>
+            <a:ext cx="3017520" cy="457200"/>
           </a:xfrm>
           <a:prstGeom prst="roundRect">
             <a:avLst>
@@ -7612,8 +7846,8 @@
         </p:nvSpPr>
         <p:spPr>
           <a:xfrm>
-            <a:off x="1645920" y="2286000"/>
-            <a:ext cx="1371600" cy="1097280"/>
+            <a:off x="731520" y="2103120"/>
+            <a:ext cx="3017520" cy="457200"/>
           </a:xfrm>
           <a:prstGeom prst="rect">
             <a:avLst/>
@@ -7627,7 +7861,7 @@
           <a:lstStyle/>
           <a:p>
             <a:pPr algn="ctr">
-              <a:defRPr sz="4400" b="1">
+              <a:defRPr sz="1600" b="1">
                 <a:solidFill>
                   <a:srgbClr val="FFFFFF"/>
                 </a:solidFill>
@@ -7635,7 +7869,7 @@
               </a:defRPr>
             </a:pPr>
             <a:r>
-              <a:t>N</a:t>
+              <a:t>IA Faible (Narrow AI)</a:t>
             </a:r>
           </a:p>
         </p:txBody>
@@ -7648,8 +7882,8 @@
         </p:nvSpPr>
         <p:spPr>
           <a:xfrm>
-            <a:off x="822960" y="3657600"/>
-            <a:ext cx="3017520" cy="548640"/>
+            <a:off x="731520" y="2743200"/>
+            <a:ext cx="3017520" cy="3200400"/>
           </a:xfrm>
           <a:prstGeom prst="rect">
             <a:avLst/>
@@ -7662,16 +7896,37 @@
           </a:bodyPr>
           <a:lstStyle/>
           <a:p>
-            <a:pPr algn="ctr">
-              <a:defRPr sz="1800" b="1">
-                <a:solidFill>
-                  <a:srgbClr val="818CF8"/>
-                </a:solidFill>
-                <a:latin typeface="Calibri"/>
-              </a:defRPr>
-            </a:pPr>
-            <a:r>
-              <a:t>IA Faible (Narrow AI)</a:t>
+            <a:pPr algn="l">
+              <a:defRPr sz="1200" b="0">
+                <a:solidFill>
+                  <a:srgbClr val="B3B3B3"/>
+                </a:solidFill>
+                <a:latin typeface="Calibri"/>
+              </a:defRPr>
+            </a:pPr>
+            <a:r>
+              <a:t>Concue pour UNE tache specifique.</a:t>
+            </a:r>
+            <a:br/>
+            <a:br/>
+            <a:r>
+              <a:t>Exemples concrets :</a:t>
+            </a:r>
+            <a:br/>
+            <a:r>
+              <a:t>* Siri et Alexa</a:t>
+            </a:r>
+            <a:br/>
+            <a:r>
+              <a:t>* Filtres spam Gmail</a:t>
+            </a:r>
+            <a:br/>
+            <a:r>
+              <a:t>* Recommandations Netflix</a:t>
+            </a:r>
+            <a:br/>
+            <a:r>
+              <a:t>* Google Translate</a:t>
             </a:r>
           </a:p>
         </p:txBody>
@@ -7684,8 +7939,8 @@
         </p:nvSpPr>
         <p:spPr>
           <a:xfrm>
-            <a:off x="822960" y="4206240"/>
-            <a:ext cx="3017520" cy="1828800"/>
+            <a:off x="731520" y="5943600"/>
+            <a:ext cx="3017520" cy="365760"/>
           </a:xfrm>
           <a:prstGeom prst="rect">
             <a:avLst/>
@@ -7699,20 +7954,15 @@
           <a:lstStyle/>
           <a:p>
             <a:pPr algn="ctr">
-              <a:defRPr sz="1300" b="0">
-                <a:solidFill>
-                  <a:srgbClr val="B3B3B3"/>
-                </a:solidFill>
-                <a:latin typeface="Calibri"/>
-              </a:defRPr>
-            </a:pPr>
-            <a:r>
-              <a:t>Concue pour une tache specifique. C'est le type d'IA le plus courant aujourd'hui.</a:t>
-            </a:r>
-            <a:br/>
-            <a:br/>
-            <a:r>
-              <a:t>Exemples : Siri, Alexa, filtres de spam, recommandations Netflix.</a:t>
+              <a:defRPr sz="1100" b="1">
+                <a:solidFill>
+                  <a:srgbClr val="818CF8"/>
+                </a:solidFill>
+                <a:latin typeface="Calibri"/>
+              </a:defRPr>
+            </a:pPr>
+            <a:r>
+              <a:t>Le type le plus courant</a:t>
             </a:r>
           </a:p>
         </p:txBody>
@@ -7725,8 +7975,8 @@
         </p:nvSpPr>
         <p:spPr>
           <a:xfrm>
-            <a:off x="4389120" y="1828800"/>
-            <a:ext cx="3566160" cy="4389120"/>
+            <a:off x="4297680" y="1828800"/>
+            <a:ext cx="3566160" cy="4572000"/>
           </a:xfrm>
           <a:prstGeom prst="roundRect">
             <a:avLst>
@@ -7770,8 +8020,8 @@
         </p:nvSpPr>
         <p:spPr>
           <a:xfrm>
-            <a:off x="5486400" y="2103120"/>
-            <a:ext cx="1371600" cy="1371600"/>
+            <a:off x="4572000" y="2103120"/>
+            <a:ext cx="3017520" cy="457200"/>
           </a:xfrm>
           <a:prstGeom prst="roundRect">
             <a:avLst>
@@ -7815,8 +8065,8 @@
         </p:nvSpPr>
         <p:spPr>
           <a:xfrm>
-            <a:off x="5486400" y="2286000"/>
-            <a:ext cx="1371600" cy="1097280"/>
+            <a:off x="4572000" y="2103120"/>
+            <a:ext cx="3017520" cy="457200"/>
           </a:xfrm>
           <a:prstGeom prst="rect">
             <a:avLst/>
@@ -7830,7 +8080,7 @@
           <a:lstStyle/>
           <a:p>
             <a:pPr algn="ctr">
-              <a:defRPr sz="4400" b="1">
+              <a:defRPr sz="1600" b="1">
                 <a:solidFill>
                   <a:srgbClr val="FFFFFF"/>
                 </a:solidFill>
@@ -7838,7 +8088,7 @@
               </a:defRPr>
             </a:pPr>
             <a:r>
-              <a:t>G</a:t>
+              <a:t>IA Forte (General AI)</a:t>
             </a:r>
           </a:p>
         </p:txBody>
@@ -7851,8 +8101,8 @@
         </p:nvSpPr>
         <p:spPr>
           <a:xfrm>
-            <a:off x="4663440" y="3657600"/>
-            <a:ext cx="3017520" cy="548640"/>
+            <a:off x="4572000" y="2743200"/>
+            <a:ext cx="3017520" cy="3200400"/>
           </a:xfrm>
           <a:prstGeom prst="rect">
             <a:avLst/>
@@ -7865,16 +8115,34 @@
           </a:bodyPr>
           <a:lstStyle/>
           <a:p>
-            <a:pPr algn="ctr">
-              <a:defRPr sz="1800" b="1">
-                <a:solidFill>
-                  <a:srgbClr val="C084FC"/>
-                </a:solidFill>
-                <a:latin typeface="Calibri"/>
-              </a:defRPr>
-            </a:pPr>
-            <a:r>
-              <a:t>IA Forte (General AI)</a:t>
+            <a:pPr algn="l">
+              <a:defRPr sz="1200" b="0">
+                <a:solidFill>
+                  <a:srgbClr val="B3B3B3"/>
+                </a:solidFill>
+                <a:latin typeface="Calibri"/>
+              </a:defRPr>
+            </a:pPr>
+            <a:r>
+              <a:t>Pourrait comprendre et apprendre N'IMPORTE quelle tache comme un humain.</a:t>
+            </a:r>
+            <a:br/>
+            <a:br/>
+            <a:r>
+              <a:t>Exemples hypothetiques :</a:t>
+            </a:r>
+            <a:br/>
+            <a:r>
+              <a:t>* Robot qui apprend tout seul</a:t>
+            </a:r>
+            <a:br/>
+            <a:r>
+              <a:t>* IA qui ressent des emotions</a:t>
+            </a:r>
+            <a:br/>
+            <a:br/>
+            <a:r>
+              <a:t>N'existe PAS encore.</a:t>
             </a:r>
           </a:p>
         </p:txBody>
@@ -7887,8 +8155,8 @@
         </p:nvSpPr>
         <p:spPr>
           <a:xfrm>
-            <a:off x="4663440" y="4206240"/>
-            <a:ext cx="3017520" cy="1828800"/>
+            <a:off x="4572000" y="5943600"/>
+            <a:ext cx="3017520" cy="365760"/>
           </a:xfrm>
           <a:prstGeom prst="rect">
             <a:avLst/>
@@ -7902,20 +8170,15 @@
           <a:lstStyle/>
           <a:p>
             <a:pPr algn="ctr">
-              <a:defRPr sz="1300" b="0">
-                <a:solidFill>
-                  <a:srgbClr val="B3B3B3"/>
-                </a:solidFill>
-                <a:latin typeface="Calibri"/>
-              </a:defRPr>
-            </a:pPr>
-            <a:r>
-              <a:t>Une IA qui pourrait comprendre et apprendre n'importe quelle tache intellectuelle comme un humain.</a:t>
-            </a:r>
-            <a:br/>
-            <a:br/>
-            <a:r>
-              <a:t>Ce type n'existe pas encore mais fait l'objet de recherches actives.</a:t>
+              <a:defRPr sz="1100" b="1">
+                <a:solidFill>
+                  <a:srgbClr val="C084FC"/>
+                </a:solidFill>
+                <a:latin typeface="Calibri"/>
+              </a:defRPr>
+            </a:pPr>
+            <a:r>
+              <a:t>En cours de recherche</a:t>
             </a:r>
           </a:p>
         </p:txBody>
@@ -7928,8 +8191,8 @@
         </p:nvSpPr>
         <p:spPr>
           <a:xfrm>
-            <a:off x="8229600" y="1828800"/>
-            <a:ext cx="3566160" cy="4389120"/>
+            <a:off x="8138160" y="1828800"/>
+            <a:ext cx="3566160" cy="4572000"/>
           </a:xfrm>
           <a:prstGeom prst="roundRect">
             <a:avLst>
@@ -7973,8 +8236,8 @@
         </p:nvSpPr>
         <p:spPr>
           <a:xfrm>
-            <a:off x="9326880" y="2103120"/>
-            <a:ext cx="1371600" cy="1371600"/>
+            <a:off x="8412480" y="2103120"/>
+            <a:ext cx="3017520" cy="457200"/>
           </a:xfrm>
           <a:prstGeom prst="roundRect">
             <a:avLst>
@@ -8018,8 +8281,8 @@
         </p:nvSpPr>
         <p:spPr>
           <a:xfrm>
-            <a:off x="9326880" y="2286000"/>
-            <a:ext cx="1371600" cy="1097280"/>
+            <a:off x="8412480" y="2103120"/>
+            <a:ext cx="3017520" cy="457200"/>
           </a:xfrm>
           <a:prstGeom prst="rect">
             <a:avLst/>
@@ -8033,7 +8296,7 @@
           <a:lstStyle/>
           <a:p>
             <a:pPr algn="ctr">
-              <a:defRPr sz="4400" b="1">
+              <a:defRPr sz="1600" b="1">
                 <a:solidFill>
                   <a:srgbClr val="FFFFFF"/>
                 </a:solidFill>
@@ -8041,7 +8304,7 @@
               </a:defRPr>
             </a:pPr>
             <a:r>
-              <a:t>S</a:t>
+              <a:t>Super IA (Super AI)</a:t>
             </a:r>
           </a:p>
         </p:txBody>
@@ -8054,8 +8317,8 @@
         </p:nvSpPr>
         <p:spPr>
           <a:xfrm>
-            <a:off x="8503920" y="3657600"/>
-            <a:ext cx="3017520" cy="548640"/>
+            <a:off x="8412480" y="2743200"/>
+            <a:ext cx="3017520" cy="3200400"/>
           </a:xfrm>
           <a:prstGeom prst="rect">
             <a:avLst/>
@@ -8068,16 +8331,26 @@
           </a:bodyPr>
           <a:lstStyle/>
           <a:p>
-            <a:pPr algn="ctr">
-              <a:defRPr sz="1800" b="1">
-                <a:solidFill>
-                  <a:srgbClr val="F472B6"/>
-                </a:solidFill>
-                <a:latin typeface="Calibri"/>
-              </a:defRPr>
-            </a:pPr>
-            <a:r>
-              <a:t>Super IA (Super AI)</a:t>
+            <a:pPr algn="l">
+              <a:defRPr sz="1200" b="0">
+                <a:solidFill>
+                  <a:srgbClr val="B3B3B3"/>
+                </a:solidFill>
+                <a:latin typeface="Calibri"/>
+              </a:defRPr>
+            </a:pPr>
+            <a:r>
+              <a:t>Depasserait l'intelligence humaine dans TOUS les domaines.</a:t>
+            </a:r>
+            <a:br/>
+            <a:br/>
+            <a:r>
+              <a:t>Concept theorique qui souleve des questions ethiques majeures.</a:t>
+            </a:r>
+            <a:br/>
+            <a:br/>
+            <a:r>
+              <a:t>Estimation : 2050-2100 ?</a:t>
             </a:r>
           </a:p>
         </p:txBody>
@@ -8090,8 +8363,8 @@
         </p:nvSpPr>
         <p:spPr>
           <a:xfrm>
-            <a:off x="8503920" y="4206240"/>
-            <a:ext cx="3017520" cy="1828800"/>
+            <a:off x="8412480" y="5943600"/>
+            <a:ext cx="3017520" cy="365760"/>
           </a:xfrm>
           <a:prstGeom prst="rect">
             <a:avLst/>
@@ -8105,20 +8378,15 @@
           <a:lstStyle/>
           <a:p>
             <a:pPr algn="ctr">
-              <a:defRPr sz="1300" b="0">
-                <a:solidFill>
-                  <a:srgbClr val="B3B3B3"/>
-                </a:solidFill>
-                <a:latin typeface="Calibri"/>
-              </a:defRPr>
-            </a:pPr>
-            <a:r>
-              <a:t>Une IA hypothetique qui depasserait l'intelligence humaine dans tous les domaines.</a:t>
-            </a:r>
-            <a:br/>
-            <a:br/>
-            <a:r>
-              <a:t>C'est un concept theorique qui souleve beaucoup de questions ethiques.</a:t>
+              <a:defRPr sz="1100" b="1">
+                <a:solidFill>
+                  <a:srgbClr val="F472B6"/>
+                </a:solidFill>
+                <a:latin typeface="Calibri"/>
+              </a:defRPr>
+            </a:pPr>
+            <a:r>
+              <a:t>Concept theorique</a:t>
             </a:r>
           </a:p>
         </p:txBody>
@@ -8264,20 +8532,44 @@
           </a:p>
         </p:txBody>
       </p:sp>
-      <p:sp>
-        <p:nvSpPr>
-          <p:cNvPr id="5" name="Rounded Rectangle 4"/>
+      <p:pic>
+        <p:nvPicPr>
+          <p:cNvPr id="5" name="Picture 4" descr="ai-network.jpg"/>
+          <p:cNvPicPr>
+            <a:picLocks noChangeAspect="1"/>
+          </p:cNvPicPr>
+          <p:nvPr/>
+        </p:nvPicPr>
+        <p:blipFill>
+          <a:blip r:embed="rId2"/>
+          <a:stretch>
+            <a:fillRect/>
+          </a:stretch>
+        </p:blipFill>
+        <p:spPr>
+          <a:xfrm>
+            <a:off x="6858000" y="1645920"/>
+            <a:ext cx="5029200" cy="2824734"/>
+          </a:xfrm>
+          <a:prstGeom prst="rect">
+            <a:avLst/>
+          </a:prstGeom>
+        </p:spPr>
+      </p:pic>
+      <p:sp>
+        <p:nvSpPr>
+          <p:cNvPr id="6" name="Rounded Rectangle 5"/>
           <p:cNvSpPr/>
           <p:nvPr/>
         </p:nvSpPr>
         <p:spPr>
           <a:xfrm>
             <a:off x="548640" y="1828800"/>
-            <a:ext cx="5486400" cy="2103120"/>
+            <a:ext cx="5943600" cy="1051560"/>
           </a:xfrm>
           <a:prstGeom prst="roundRect">
             <a:avLst>
-              <a:gd name="adj" fmla="val 4000"/>
+              <a:gd name="adj" fmla="val 3000"/>
             </a:avLst>
           </a:prstGeom>
           <a:solidFill>
@@ -8311,14 +8603,14 @@
       </p:sp>
       <p:sp>
         <p:nvSpPr>
-          <p:cNvPr id="6" name="TextBox 5"/>
+          <p:cNvPr id="7" name="TextBox 6"/>
           <p:cNvSpPr txBox="1"/>
           <p:nvPr/>
         </p:nvSpPr>
         <p:spPr>
           <a:xfrm>
-            <a:off x="914400" y="2103120"/>
-            <a:ext cx="4754880" cy="457200"/>
+            <a:off x="822960" y="1920240"/>
+            <a:ext cx="5486400" cy="365760"/>
           </a:xfrm>
           <a:prstGeom prst="rect">
             <a:avLst/>
@@ -8332,7 +8624,7 @@
           <a:lstStyle/>
           <a:p>
             <a:pPr algn="l">
-              <a:defRPr sz="2000" b="1">
+              <a:defRPr sz="1700" b="1">
                 <a:solidFill>
                   <a:srgbClr val="C084FC"/>
                 </a:solidFill>
@@ -8347,14 +8639,14 @@
       </p:sp>
       <p:sp>
         <p:nvSpPr>
-          <p:cNvPr id="7" name="TextBox 6"/>
+          <p:cNvPr id="8" name="TextBox 7"/>
           <p:cNvSpPr txBox="1"/>
           <p:nvPr/>
         </p:nvSpPr>
         <p:spPr>
           <a:xfrm>
-            <a:off x="914400" y="2651760"/>
-            <a:ext cx="4754880" cy="1097280"/>
+            <a:off x="822960" y="2286000"/>
+            <a:ext cx="5486400" cy="548640"/>
           </a:xfrm>
           <a:prstGeom prst="rect">
             <a:avLst/>
@@ -8368,7 +8660,7 @@
           <a:lstStyle/>
           <a:p>
             <a:pPr algn="l">
-              <a:defRPr sz="1500" b="0">
+              <a:defRPr sz="1200" b="0">
                 <a:solidFill>
                   <a:srgbClr val="B3B3B3"/>
                 </a:solidFill>
@@ -8376,25 +8668,29 @@
               </a:defRPr>
             </a:pPr>
             <a:r>
-              <a:t>L'IA a besoin de grandes quantites de donnees pour apprendre. Plus les donnees sont nombreuses et de qualite, meilleure sera l'IA.</a:t>
-            </a:r>
-          </a:p>
-        </p:txBody>
-      </p:sp>
-      <p:sp>
-        <p:nvSpPr>
-          <p:cNvPr id="8" name="Rounded Rectangle 7"/>
+              <a:t>L'IA a besoin de GRANDES quantites de donnees pour apprendre.</a:t>
+            </a:r>
+            <a:br/>
+            <a:r>
+              <a:t>Exemple : Des millions de photos de chats pour apprendre a reconnaitre un chat.</a:t>
+            </a:r>
+          </a:p>
+        </p:txBody>
+      </p:sp>
+      <p:sp>
+        <p:nvSpPr>
+          <p:cNvPr id="9" name="Rounded Rectangle 8"/>
           <p:cNvSpPr/>
           <p:nvPr/>
         </p:nvSpPr>
         <p:spPr>
           <a:xfrm>
-            <a:off x="6400800" y="1828800"/>
-            <a:ext cx="5486400" cy="2103120"/>
+            <a:off x="548640" y="3017520"/>
+            <a:ext cx="5943600" cy="1051560"/>
           </a:xfrm>
           <a:prstGeom prst="roundRect">
             <a:avLst>
-              <a:gd name="adj" fmla="val 4000"/>
+              <a:gd name="adj" fmla="val 3000"/>
             </a:avLst>
           </a:prstGeom>
           <a:solidFill>
@@ -8428,14 +8724,14 @@
       </p:sp>
       <p:sp>
         <p:nvSpPr>
-          <p:cNvPr id="9" name="TextBox 8"/>
+          <p:cNvPr id="10" name="TextBox 9"/>
           <p:cNvSpPr txBox="1"/>
           <p:nvPr/>
         </p:nvSpPr>
         <p:spPr>
           <a:xfrm>
-            <a:off x="6766560" y="2103120"/>
-            <a:ext cx="4754880" cy="457200"/>
+            <a:off x="822960" y="3108960"/>
+            <a:ext cx="5486400" cy="365760"/>
           </a:xfrm>
           <a:prstGeom prst="rect">
             <a:avLst/>
@@ -8449,7 +8745,7 @@
           <a:lstStyle/>
           <a:p>
             <a:pPr algn="l">
-              <a:defRPr sz="2000" b="1">
+              <a:defRPr sz="1700" b="1">
                 <a:solidFill>
                   <a:srgbClr val="C084FC"/>
                 </a:solidFill>
@@ -8464,14 +8760,14 @@
       </p:sp>
       <p:sp>
         <p:nvSpPr>
-          <p:cNvPr id="10" name="TextBox 9"/>
+          <p:cNvPr id="11" name="TextBox 10"/>
           <p:cNvSpPr txBox="1"/>
           <p:nvPr/>
         </p:nvSpPr>
         <p:spPr>
           <a:xfrm>
-            <a:off x="6766560" y="2651760"/>
-            <a:ext cx="4754880" cy="1097280"/>
+            <a:off x="822960" y="3474720"/>
+            <a:ext cx="5486400" cy="548640"/>
           </a:xfrm>
           <a:prstGeom prst="rect">
             <a:avLst/>
@@ -8485,7 +8781,7 @@
           <a:lstStyle/>
           <a:p>
             <a:pPr algn="l">
-              <a:defRPr sz="1500" b="0">
+              <a:defRPr sz="1200" b="0">
                 <a:solidFill>
                   <a:srgbClr val="B3B3B3"/>
                 </a:solidFill>
@@ -8493,25 +8789,29 @@
               </a:defRPr>
             </a:pPr>
             <a:r>
-              <a:t>Des regles mathematiques permettent a l'IA d'analyser les donnees, de trouver des patterns et de prendre des decisions.</a:t>
-            </a:r>
-          </a:p>
-        </p:txBody>
-      </p:sp>
-      <p:sp>
-        <p:nvSpPr>
-          <p:cNvPr id="11" name="Rounded Rectangle 10"/>
+              <a:t>Des regles mathematiques analysent les donnees.</a:t>
+            </a:r>
+            <a:br/>
+            <a:r>
+              <a:t>Exemple : Un algorithme de tri qui classe les emails en spam ou non-spam.</a:t>
+            </a:r>
+          </a:p>
+        </p:txBody>
+      </p:sp>
+      <p:sp>
+        <p:nvSpPr>
+          <p:cNvPr id="12" name="Rounded Rectangle 11"/>
           <p:cNvSpPr/>
           <p:nvPr/>
         </p:nvSpPr>
         <p:spPr>
           <a:xfrm>
             <a:off x="548640" y="4206240"/>
-            <a:ext cx="5486400" cy="2103120"/>
+            <a:ext cx="5943600" cy="1051560"/>
           </a:xfrm>
           <a:prstGeom prst="roundRect">
             <a:avLst>
-              <a:gd name="adj" fmla="val 4000"/>
+              <a:gd name="adj" fmla="val 3000"/>
             </a:avLst>
           </a:prstGeom>
           <a:solidFill>
@@ -8545,14 +8845,14 @@
       </p:sp>
       <p:sp>
         <p:nvSpPr>
-          <p:cNvPr id="12" name="TextBox 11"/>
+          <p:cNvPr id="13" name="TextBox 12"/>
           <p:cNvSpPr txBox="1"/>
           <p:nvPr/>
         </p:nvSpPr>
         <p:spPr>
           <a:xfrm>
-            <a:off x="914400" y="4480560"/>
-            <a:ext cx="4754880" cy="457200"/>
+            <a:off x="822960" y="4297680"/>
+            <a:ext cx="5486400" cy="365760"/>
           </a:xfrm>
           <a:prstGeom prst="rect">
             <a:avLst/>
@@ -8566,7 +8866,7 @@
           <a:lstStyle/>
           <a:p>
             <a:pPr algn="l">
-              <a:defRPr sz="2000" b="1">
+              <a:defRPr sz="1700" b="1">
                 <a:solidFill>
                   <a:srgbClr val="C084FC"/>
                 </a:solidFill>
@@ -8574,21 +8874,21 @@
               </a:defRPr>
             </a:pPr>
             <a:r>
-              <a:t>3. L'Apprentissage</a:t>
-            </a:r>
-          </a:p>
-        </p:txBody>
-      </p:sp>
-      <p:sp>
-        <p:nvSpPr>
-          <p:cNvPr id="13" name="TextBox 12"/>
+              <a:t>3. Machine Learning</a:t>
+            </a:r>
+          </a:p>
+        </p:txBody>
+      </p:sp>
+      <p:sp>
+        <p:nvSpPr>
+          <p:cNvPr id="14" name="TextBox 13"/>
           <p:cNvSpPr txBox="1"/>
           <p:nvPr/>
         </p:nvSpPr>
         <p:spPr>
           <a:xfrm>
-            <a:off x="914400" y="5029200"/>
-            <a:ext cx="4754880" cy="1097280"/>
+            <a:off x="822960" y="4663440"/>
+            <a:ext cx="5486400" cy="548640"/>
           </a:xfrm>
           <a:prstGeom prst="rect">
             <a:avLst/>
@@ -8602,7 +8902,7 @@
           <a:lstStyle/>
           <a:p>
             <a:pPr algn="l">
-              <a:defRPr sz="1500" b="0">
+              <a:defRPr sz="1200" b="0">
                 <a:solidFill>
                   <a:srgbClr val="B3B3B3"/>
                 </a:solidFill>
@@ -8610,25 +8910,29 @@
               </a:defRPr>
             </a:pPr>
             <a:r>
-              <a:t>L'IA s'ameliore en s'entrainant sur des donnees. Elle ajuste ses parametres pour obtenir de meilleurs resultats a chaque iteration.</a:t>
-            </a:r>
-          </a:p>
-        </p:txBody>
-      </p:sp>
-      <p:sp>
-        <p:nvSpPr>
-          <p:cNvPr id="14" name="Rounded Rectangle 13"/>
+              <a:t>L'IA s'ameliore en s'entrainant. Elle apprend de ses erreurs.</a:t>
+            </a:r>
+            <a:br/>
+            <a:r>
+              <a:t>Exemple : YouTube apprend vos gouts en analysant ce que vous regardez.</a:t>
+            </a:r>
+          </a:p>
+        </p:txBody>
+      </p:sp>
+      <p:sp>
+        <p:nvSpPr>
+          <p:cNvPr id="15" name="Rounded Rectangle 14"/>
           <p:cNvSpPr/>
           <p:nvPr/>
         </p:nvSpPr>
         <p:spPr>
           <a:xfrm>
-            <a:off x="6400800" y="4206240"/>
-            <a:ext cx="5486400" cy="2103120"/>
+            <a:off x="548640" y="5394960"/>
+            <a:ext cx="5943600" cy="1051560"/>
           </a:xfrm>
           <a:prstGeom prst="roundRect">
             <a:avLst>
-              <a:gd name="adj" fmla="val 4000"/>
+              <a:gd name="adj" fmla="val 3000"/>
             </a:avLst>
           </a:prstGeom>
           <a:solidFill>
@@ -8662,14 +8966,14 @@
       </p:sp>
       <p:sp>
         <p:nvSpPr>
-          <p:cNvPr id="15" name="TextBox 14"/>
+          <p:cNvPr id="16" name="TextBox 15"/>
           <p:cNvSpPr txBox="1"/>
           <p:nvPr/>
         </p:nvSpPr>
         <p:spPr>
           <a:xfrm>
-            <a:off x="6766560" y="4480560"/>
-            <a:ext cx="4754880" cy="457200"/>
+            <a:off x="822960" y="5486400"/>
+            <a:ext cx="5486400" cy="365760"/>
           </a:xfrm>
           <a:prstGeom prst="rect">
             <a:avLst/>
@@ -8683,7 +8987,7 @@
           <a:lstStyle/>
           <a:p>
             <a:pPr algn="l">
-              <a:defRPr sz="2000" b="1">
+              <a:defRPr sz="1700" b="1">
                 <a:solidFill>
                   <a:srgbClr val="C084FC"/>
                 </a:solidFill>
@@ -8698,14 +9002,14 @@
       </p:sp>
       <p:sp>
         <p:nvSpPr>
-          <p:cNvPr id="16" name="TextBox 15"/>
+          <p:cNvPr id="17" name="TextBox 16"/>
           <p:cNvSpPr txBox="1"/>
           <p:nvPr/>
         </p:nvSpPr>
         <p:spPr>
           <a:xfrm>
-            <a:off x="6766560" y="5029200"/>
-            <a:ext cx="4754880" cy="1097280"/>
+            <a:off x="822960" y="5852160"/>
+            <a:ext cx="5486400" cy="548640"/>
           </a:xfrm>
           <a:prstGeom prst="rect">
             <a:avLst/>
@@ -8719,7 +9023,7 @@
           <a:lstStyle/>
           <a:p>
             <a:pPr algn="l">
-              <a:defRPr sz="1500" b="0">
+              <a:defRPr sz="1200" b="0">
                 <a:solidFill>
                   <a:srgbClr val="B3B3B3"/>
                 </a:solidFill>
@@ -8727,7 +9031,11 @@
               </a:defRPr>
             </a:pPr>
             <a:r>
-              <a:t>Inspires du cerveau humain, ces reseaux sont composes de couches de 'neurones' artificiels qui traitent l'information de maniere hierarchique.</a:t>
+              <a:t>Inspires du cerveau humain, avec des couches de neurones artificiels.</a:t>
+            </a:r>
+            <a:br/>
+            <a:r>
+              <a:t>Exemple : La reconnaissance faciale de votre telephone.</a:t>
             </a:r>
           </a:p>
         </p:txBody>
@@ -8873,20 +9181,44 @@
           </a:p>
         </p:txBody>
       </p:sp>
-      <p:sp>
-        <p:nvSpPr>
-          <p:cNvPr id="5" name="Rounded Rectangle 4"/>
+      <p:pic>
+        <p:nvPicPr>
+          <p:cNvPr id="5" name="Picture 4" descr="ai-medical.jpg"/>
+          <p:cNvPicPr>
+            <a:picLocks noChangeAspect="1"/>
+          </p:cNvPicPr>
+          <p:nvPr/>
+        </p:nvPicPr>
+        <p:blipFill>
+          <a:blip r:embed="rId2"/>
+          <a:stretch>
+            <a:fillRect/>
+          </a:stretch>
+        </p:blipFill>
+        <p:spPr>
+          <a:xfrm>
+            <a:off x="7772400" y="1645920"/>
+            <a:ext cx="4114800" cy="2318004"/>
+          </a:xfrm>
+          <a:prstGeom prst="rect">
+            <a:avLst/>
+          </a:prstGeom>
+        </p:spPr>
+      </p:pic>
+      <p:sp>
+        <p:nvSpPr>
+          <p:cNvPr id="6" name="Rounded Rectangle 5"/>
           <p:cNvSpPr/>
           <p:nvPr/>
         </p:nvSpPr>
         <p:spPr>
           <a:xfrm>
             <a:off x="457200" y="1828800"/>
-            <a:ext cx="3566160" cy="2103120"/>
+            <a:ext cx="6858000" cy="658368"/>
           </a:xfrm>
           <a:prstGeom prst="roundRect">
             <a:avLst>
-              <a:gd name="adj" fmla="val 4000"/>
+              <a:gd name="adj" fmla="val 2000"/>
             </a:avLst>
           </a:prstGeom>
           <a:solidFill>
@@ -8920,14 +9252,57 @@
       </p:sp>
       <p:sp>
         <p:nvSpPr>
-          <p:cNvPr id="6" name="TextBox 5"/>
+          <p:cNvPr id="7" name="Oval 6"/>
+          <p:cNvSpPr/>
+          <p:nvPr/>
+        </p:nvSpPr>
+        <p:spPr>
+          <a:xfrm>
+            <a:off x="731520" y="2011680"/>
+            <a:ext cx="292608" cy="292608"/>
+          </a:xfrm>
+          <a:prstGeom prst="ellipse">
+            <a:avLst/>
+          </a:prstGeom>
+          <a:solidFill>
+            <a:srgbClr val="818CF8"/>
+          </a:solidFill>
+          <a:ln>
+            <a:noFill/>
+          </a:ln>
+        </p:spPr>
+        <p:style>
+          <a:lnRef idx="1">
+            <a:schemeClr val="accent1"/>
+          </a:lnRef>
+          <a:fillRef idx="3">
+            <a:schemeClr val="accent1"/>
+          </a:fillRef>
+          <a:effectRef idx="2">
+            <a:schemeClr val="accent1"/>
+          </a:effectRef>
+          <a:fontRef idx="minor">
+            <a:schemeClr val="lt1"/>
+          </a:fontRef>
+        </p:style>
+        <p:txBody>
+          <a:bodyPr rtlCol="0" anchor="ctr"/>
+          <a:lstStyle/>
+          <a:p>
+            <a:pPr algn="ctr"/>
+          </a:p>
+        </p:txBody>
+      </p:sp>
+      <p:sp>
+        <p:nvSpPr>
+          <p:cNvPr id="8" name="TextBox 7"/>
           <p:cNvSpPr txBox="1"/>
           <p:nvPr/>
         </p:nvSpPr>
         <p:spPr>
           <a:xfrm>
-            <a:off x="731520" y="2103120"/>
-            <a:ext cx="3017520" cy="457200"/>
+            <a:off x="1188720" y="1920240"/>
+            <a:ext cx="1828800" cy="457200"/>
           </a:xfrm>
           <a:prstGeom prst="rect">
             <a:avLst/>
@@ -8941,7 +9316,7 @@
           <a:lstStyle/>
           <a:p>
             <a:pPr algn="l">
-              <a:defRPr sz="2000" b="1">
+              <a:defRPr sz="1500" b="1">
                 <a:solidFill>
                   <a:srgbClr val="C084FC"/>
                 </a:solidFill>
@@ -8956,14 +9331,14 @@
       </p:sp>
       <p:sp>
         <p:nvSpPr>
-          <p:cNvPr id="7" name="TextBox 6"/>
+          <p:cNvPr id="9" name="TextBox 8"/>
           <p:cNvSpPr txBox="1"/>
           <p:nvPr/>
         </p:nvSpPr>
         <p:spPr>
           <a:xfrm>
-            <a:off x="731520" y="2651760"/>
-            <a:ext cx="3017520" cy="1097280"/>
+            <a:off x="3017520" y="1965960"/>
+            <a:ext cx="4114800" cy="411480"/>
           </a:xfrm>
           <a:prstGeom prst="rect">
             <a:avLst/>
@@ -8977,7 +9352,7 @@
           <a:lstStyle/>
           <a:p>
             <a:pPr algn="l">
-              <a:defRPr sz="1400" b="0">
+              <a:defRPr sz="1200" b="0">
                 <a:solidFill>
                   <a:srgbClr val="B3B3B3"/>
                 </a:solidFill>
@@ -8985,25 +9360,25 @@
               </a:defRPr>
             </a:pPr>
             <a:r>
-              <a:t>Diagnostic de maladies, analyse d'imagerie medicale, decouverte de medicaments, chirurgie assistee par robot.</a:t>
-            </a:r>
-          </a:p>
-        </p:txBody>
-      </p:sp>
-      <p:sp>
-        <p:nvSpPr>
-          <p:cNvPr id="8" name="Rounded Rectangle 7"/>
+              <a:t>Diagnostic par IA, analyse de radiographies, robots chirurgicaux (Da Vinci)</a:t>
+            </a:r>
+          </a:p>
+        </p:txBody>
+      </p:sp>
+      <p:sp>
+        <p:nvSpPr>
+          <p:cNvPr id="10" name="Rounded Rectangle 9"/>
           <p:cNvSpPr/>
           <p:nvPr/>
         </p:nvSpPr>
         <p:spPr>
           <a:xfrm>
-            <a:off x="4297680" y="1828800"/>
-            <a:ext cx="3566160" cy="2103120"/>
+            <a:off x="457200" y="2606040"/>
+            <a:ext cx="6858000" cy="658368"/>
           </a:xfrm>
           <a:prstGeom prst="roundRect">
             <a:avLst>
-              <a:gd name="adj" fmla="val 4000"/>
+              <a:gd name="adj" fmla="val 2000"/>
             </a:avLst>
           </a:prstGeom>
           <a:solidFill>
@@ -9037,14 +9412,57 @@
       </p:sp>
       <p:sp>
         <p:nvSpPr>
-          <p:cNvPr id="9" name="TextBox 8"/>
+          <p:cNvPr id="11" name="Oval 10"/>
+          <p:cNvSpPr/>
+          <p:nvPr/>
+        </p:nvSpPr>
+        <p:spPr>
+          <a:xfrm>
+            <a:off x="731520" y="2788920"/>
+            <a:ext cx="292608" cy="292608"/>
+          </a:xfrm>
+          <a:prstGeom prst="ellipse">
+            <a:avLst/>
+          </a:prstGeom>
+          <a:solidFill>
+            <a:srgbClr val="818CF8"/>
+          </a:solidFill>
+          <a:ln>
+            <a:noFill/>
+          </a:ln>
+        </p:spPr>
+        <p:style>
+          <a:lnRef idx="1">
+            <a:schemeClr val="accent1"/>
+          </a:lnRef>
+          <a:fillRef idx="3">
+            <a:schemeClr val="accent1"/>
+          </a:fillRef>
+          <a:effectRef idx="2">
+            <a:schemeClr val="accent1"/>
+          </a:effectRef>
+          <a:fontRef idx="minor">
+            <a:schemeClr val="lt1"/>
+          </a:fontRef>
+        </p:style>
+        <p:txBody>
+          <a:bodyPr rtlCol="0" anchor="ctr"/>
+          <a:lstStyle/>
+          <a:p>
+            <a:pPr algn="ctr"/>
+          </a:p>
+        </p:txBody>
+      </p:sp>
+      <p:sp>
+        <p:nvSpPr>
+          <p:cNvPr id="12" name="TextBox 11"/>
           <p:cNvSpPr txBox="1"/>
           <p:nvPr/>
         </p:nvSpPr>
         <p:spPr>
           <a:xfrm>
-            <a:off x="4572000" y="2103120"/>
-            <a:ext cx="3017520" cy="457200"/>
+            <a:off x="1188720" y="2697480"/>
+            <a:ext cx="1828800" cy="457200"/>
           </a:xfrm>
           <a:prstGeom prst="rect">
             <a:avLst/>
@@ -9058,7 +9476,7 @@
           <a:lstStyle/>
           <a:p>
             <a:pPr algn="l">
-              <a:defRPr sz="2000" b="1">
+              <a:defRPr sz="1500" b="1">
                 <a:solidFill>
                   <a:srgbClr val="C084FC"/>
                 </a:solidFill>
@@ -9073,14 +9491,14 @@
       </p:sp>
       <p:sp>
         <p:nvSpPr>
-          <p:cNvPr id="10" name="TextBox 9"/>
+          <p:cNvPr id="13" name="TextBox 12"/>
           <p:cNvSpPr txBox="1"/>
           <p:nvPr/>
         </p:nvSpPr>
         <p:spPr>
           <a:xfrm>
-            <a:off x="4572000" y="2651760"/>
-            <a:ext cx="3017520" cy="1097280"/>
+            <a:off x="3017520" y="2743200"/>
+            <a:ext cx="4114800" cy="411480"/>
           </a:xfrm>
           <a:prstGeom prst="rect">
             <a:avLst/>
@@ -9094,7 +9512,7 @@
           <a:lstStyle/>
           <a:p>
             <a:pPr algn="l">
-              <a:defRPr sz="1400" b="0">
+              <a:defRPr sz="1200" b="0">
                 <a:solidFill>
                   <a:srgbClr val="B3B3B3"/>
                 </a:solidFill>
@@ -9102,25 +9520,25 @@
               </a:defRPr>
             </a:pPr>
             <a:r>
-              <a:t>Voitures autonomes (Tesla, Waymo), optimisation du trafic, systemes de navigation intelligents.</a:t>
-            </a:r>
-          </a:p>
-        </p:txBody>
-      </p:sp>
-      <p:sp>
-        <p:nvSpPr>
-          <p:cNvPr id="11" name="Rounded Rectangle 10"/>
+              <a:t>Tesla Autopilot, Google Waymo, GPS intelligents, Uber/Lyft</a:t>
+            </a:r>
+          </a:p>
+        </p:txBody>
+      </p:sp>
+      <p:sp>
+        <p:nvSpPr>
+          <p:cNvPr id="14" name="Rounded Rectangle 13"/>
           <p:cNvSpPr/>
           <p:nvPr/>
         </p:nvSpPr>
         <p:spPr>
           <a:xfrm>
-            <a:off x="8138160" y="1828800"/>
-            <a:ext cx="3566160" cy="2103120"/>
+            <a:off x="457200" y="3383280"/>
+            <a:ext cx="6858000" cy="658368"/>
           </a:xfrm>
           <a:prstGeom prst="roundRect">
             <a:avLst>
-              <a:gd name="adj" fmla="val 4000"/>
+              <a:gd name="adj" fmla="val 2000"/>
             </a:avLst>
           </a:prstGeom>
           <a:solidFill>
@@ -9154,14 +9572,57 @@
       </p:sp>
       <p:sp>
         <p:nvSpPr>
-          <p:cNvPr id="12" name="TextBox 11"/>
+          <p:cNvPr id="15" name="Oval 14"/>
+          <p:cNvSpPr/>
+          <p:nvPr/>
+        </p:nvSpPr>
+        <p:spPr>
+          <a:xfrm>
+            <a:off x="731520" y="3566160"/>
+            <a:ext cx="292608" cy="292608"/>
+          </a:xfrm>
+          <a:prstGeom prst="ellipse">
+            <a:avLst/>
+          </a:prstGeom>
+          <a:solidFill>
+            <a:srgbClr val="818CF8"/>
+          </a:solidFill>
+          <a:ln>
+            <a:noFill/>
+          </a:ln>
+        </p:spPr>
+        <p:style>
+          <a:lnRef idx="1">
+            <a:schemeClr val="accent1"/>
+          </a:lnRef>
+          <a:fillRef idx="3">
+            <a:schemeClr val="accent1"/>
+          </a:fillRef>
+          <a:effectRef idx="2">
+            <a:schemeClr val="accent1"/>
+          </a:effectRef>
+          <a:fontRef idx="minor">
+            <a:schemeClr val="lt1"/>
+          </a:fontRef>
+        </p:style>
+        <p:txBody>
+          <a:bodyPr rtlCol="0" anchor="ctr"/>
+          <a:lstStyle/>
+          <a:p>
+            <a:pPr algn="ctr"/>
+          </a:p>
+        </p:txBody>
+      </p:sp>
+      <p:sp>
+        <p:nvSpPr>
+          <p:cNvPr id="16" name="TextBox 15"/>
           <p:cNvSpPr txBox="1"/>
           <p:nvPr/>
         </p:nvSpPr>
         <p:spPr>
           <a:xfrm>
-            <a:off x="8412480" y="2103120"/>
-            <a:ext cx="3017520" cy="457200"/>
+            <a:off x="1188720" y="3474720"/>
+            <a:ext cx="1828800" cy="457200"/>
           </a:xfrm>
           <a:prstGeom prst="rect">
             <a:avLst/>
@@ -9175,7 +9636,7 @@
           <a:lstStyle/>
           <a:p>
             <a:pPr algn="l">
-              <a:defRPr sz="2000" b="1">
+              <a:defRPr sz="1500" b="1">
                 <a:solidFill>
                   <a:srgbClr val="C084FC"/>
                 </a:solidFill>
@@ -9190,14 +9651,14 @@
       </p:sp>
       <p:sp>
         <p:nvSpPr>
-          <p:cNvPr id="13" name="TextBox 12"/>
+          <p:cNvPr id="17" name="TextBox 16"/>
           <p:cNvSpPr txBox="1"/>
           <p:nvPr/>
         </p:nvSpPr>
         <p:spPr>
           <a:xfrm>
-            <a:off x="8412480" y="2651760"/>
-            <a:ext cx="3017520" cy="1097280"/>
+            <a:off x="3017520" y="3520440"/>
+            <a:ext cx="4114800" cy="411480"/>
           </a:xfrm>
           <a:prstGeom prst="rect">
             <a:avLst/>
@@ -9211,7 +9672,7 @@
           <a:lstStyle/>
           <a:p>
             <a:pPr algn="l">
-              <a:defRPr sz="1400" b="0">
+              <a:defRPr sz="1200" b="0">
                 <a:solidFill>
                   <a:srgbClr val="B3B3B3"/>
                 </a:solidFill>
@@ -9219,25 +9680,25 @@
               </a:defRPr>
             </a:pPr>
             <a:r>
-              <a:t>Tutorat personnalise, correction automatique, plateformes d'apprentissage adaptatif.</a:t>
-            </a:r>
-          </a:p>
-        </p:txBody>
-      </p:sp>
-      <p:sp>
-        <p:nvSpPr>
-          <p:cNvPr id="14" name="Rounded Rectangle 13"/>
+              <a:t>ChatGPT pour les devoirs, Duolingo, Khan Academy, correction auto</a:t>
+            </a:r>
+          </a:p>
+        </p:txBody>
+      </p:sp>
+      <p:sp>
+        <p:nvSpPr>
+          <p:cNvPr id="18" name="Rounded Rectangle 17"/>
           <p:cNvSpPr/>
           <p:nvPr/>
         </p:nvSpPr>
         <p:spPr>
           <a:xfrm>
-            <a:off x="457200" y="4206240"/>
-            <a:ext cx="3566160" cy="2103120"/>
+            <a:off x="457200" y="4160520"/>
+            <a:ext cx="6858000" cy="658368"/>
           </a:xfrm>
           <a:prstGeom prst="roundRect">
             <a:avLst>
-              <a:gd name="adj" fmla="val 4000"/>
+              <a:gd name="adj" fmla="val 2000"/>
             </a:avLst>
           </a:prstGeom>
           <a:solidFill>
@@ -9271,14 +9732,57 @@
       </p:sp>
       <p:sp>
         <p:nvSpPr>
-          <p:cNvPr id="15" name="TextBox 14"/>
+          <p:cNvPr id="19" name="Oval 18"/>
+          <p:cNvSpPr/>
+          <p:nvPr/>
+        </p:nvSpPr>
+        <p:spPr>
+          <a:xfrm>
+            <a:off x="731520" y="4343400"/>
+            <a:ext cx="292608" cy="292608"/>
+          </a:xfrm>
+          <a:prstGeom prst="ellipse">
+            <a:avLst/>
+          </a:prstGeom>
+          <a:solidFill>
+            <a:srgbClr val="818CF8"/>
+          </a:solidFill>
+          <a:ln>
+            <a:noFill/>
+          </a:ln>
+        </p:spPr>
+        <p:style>
+          <a:lnRef idx="1">
+            <a:schemeClr val="accent1"/>
+          </a:lnRef>
+          <a:fillRef idx="3">
+            <a:schemeClr val="accent1"/>
+          </a:fillRef>
+          <a:effectRef idx="2">
+            <a:schemeClr val="accent1"/>
+          </a:effectRef>
+          <a:fontRef idx="minor">
+            <a:schemeClr val="lt1"/>
+          </a:fontRef>
+        </p:style>
+        <p:txBody>
+          <a:bodyPr rtlCol="0" anchor="ctr"/>
+          <a:lstStyle/>
+          <a:p>
+            <a:pPr algn="ctr"/>
+          </a:p>
+        </p:txBody>
+      </p:sp>
+      <p:sp>
+        <p:nvSpPr>
+          <p:cNvPr id="20" name="TextBox 19"/>
           <p:cNvSpPr txBox="1"/>
           <p:nvPr/>
         </p:nvSpPr>
         <p:spPr>
           <a:xfrm>
-            <a:off x="731520" y="4480560"/>
-            <a:ext cx="3017520" cy="457200"/>
+            <a:off x="1188720" y="4251960"/>
+            <a:ext cx="1828800" cy="457200"/>
           </a:xfrm>
           <a:prstGeom prst="rect">
             <a:avLst/>
@@ -9292,7 +9796,7 @@
           <a:lstStyle/>
           <a:p>
             <a:pPr algn="l">
-              <a:defRPr sz="2000" b="1">
+              <a:defRPr sz="1500" b="1">
                 <a:solidFill>
                   <a:srgbClr val="C084FC"/>
                 </a:solidFill>
@@ -9307,14 +9811,14 @@
       </p:sp>
       <p:sp>
         <p:nvSpPr>
-          <p:cNvPr id="16" name="TextBox 15"/>
+          <p:cNvPr id="21" name="TextBox 20"/>
           <p:cNvSpPr txBox="1"/>
           <p:nvPr/>
         </p:nvSpPr>
         <p:spPr>
           <a:xfrm>
-            <a:off x="731520" y="5029200"/>
-            <a:ext cx="3017520" cy="1097280"/>
+            <a:off x="3017520" y="4297680"/>
+            <a:ext cx="4114800" cy="411480"/>
           </a:xfrm>
           <a:prstGeom prst="rect">
             <a:avLst/>
@@ -9328,7 +9832,7 @@
           <a:lstStyle/>
           <a:p>
             <a:pPr algn="l">
-              <a:defRPr sz="1400" b="0">
+              <a:defRPr sz="1200" b="0">
                 <a:solidFill>
                   <a:srgbClr val="B3B3B3"/>
                 </a:solidFill>
@@ -9336,25 +9840,25 @@
               </a:defRPr>
             </a:pPr>
             <a:r>
-              <a:t>Personnages non-joueurs (PNJ) intelligents, generation procedurale de contenu, matchmaking.</a:t>
-            </a:r>
-          </a:p>
-        </p:txBody>
-      </p:sp>
-      <p:sp>
-        <p:nvSpPr>
-          <p:cNvPr id="17" name="Rounded Rectangle 16"/>
+              <a:t>PNJ intelligents dans GTA/FIFA, generation de mondes (Minecraft IA)</a:t>
+            </a:r>
+          </a:p>
+        </p:txBody>
+      </p:sp>
+      <p:sp>
+        <p:nvSpPr>
+          <p:cNvPr id="22" name="Rounded Rectangle 21"/>
           <p:cNvSpPr/>
           <p:nvPr/>
         </p:nvSpPr>
         <p:spPr>
           <a:xfrm>
-            <a:off x="4297680" y="4206240"/>
-            <a:ext cx="3566160" cy="2103120"/>
+            <a:off x="457200" y="4937760"/>
+            <a:ext cx="6858000" cy="658368"/>
           </a:xfrm>
           <a:prstGeom prst="roundRect">
             <a:avLst>
-              <a:gd name="adj" fmla="val 4000"/>
+              <a:gd name="adj" fmla="val 2000"/>
             </a:avLst>
           </a:prstGeom>
           <a:solidFill>
@@ -9388,14 +9892,57 @@
       </p:sp>
       <p:sp>
         <p:nvSpPr>
-          <p:cNvPr id="18" name="TextBox 17"/>
+          <p:cNvPr id="23" name="Oval 22"/>
+          <p:cNvSpPr/>
+          <p:nvPr/>
+        </p:nvSpPr>
+        <p:spPr>
+          <a:xfrm>
+            <a:off x="731520" y="5120640"/>
+            <a:ext cx="292608" cy="292608"/>
+          </a:xfrm>
+          <a:prstGeom prst="ellipse">
+            <a:avLst/>
+          </a:prstGeom>
+          <a:solidFill>
+            <a:srgbClr val="818CF8"/>
+          </a:solidFill>
+          <a:ln>
+            <a:noFill/>
+          </a:ln>
+        </p:spPr>
+        <p:style>
+          <a:lnRef idx="1">
+            <a:schemeClr val="accent1"/>
+          </a:lnRef>
+          <a:fillRef idx="3">
+            <a:schemeClr val="accent1"/>
+          </a:fillRef>
+          <a:effectRef idx="2">
+            <a:schemeClr val="accent1"/>
+          </a:effectRef>
+          <a:fontRef idx="minor">
+            <a:schemeClr val="lt1"/>
+          </a:fontRef>
+        </p:style>
+        <p:txBody>
+          <a:bodyPr rtlCol="0" anchor="ctr"/>
+          <a:lstStyle/>
+          <a:p>
+            <a:pPr algn="ctr"/>
+          </a:p>
+        </p:txBody>
+      </p:sp>
+      <p:sp>
+        <p:nvSpPr>
+          <p:cNvPr id="24" name="TextBox 23"/>
           <p:cNvSpPr txBox="1"/>
           <p:nvPr/>
         </p:nvSpPr>
         <p:spPr>
           <a:xfrm>
-            <a:off x="4572000" y="4480560"/>
-            <a:ext cx="3017520" cy="457200"/>
+            <a:off x="1188720" y="5029200"/>
+            <a:ext cx="1828800" cy="457200"/>
           </a:xfrm>
           <a:prstGeom prst="rect">
             <a:avLst/>
@@ -9409,7 +9956,7 @@
           <a:lstStyle/>
           <a:p>
             <a:pPr algn="l">
-              <a:defRPr sz="2000" b="1">
+              <a:defRPr sz="1500" b="1">
                 <a:solidFill>
                   <a:srgbClr val="C084FC"/>
                 </a:solidFill>
@@ -9424,14 +9971,14 @@
       </p:sp>
       <p:sp>
         <p:nvSpPr>
-          <p:cNvPr id="19" name="TextBox 18"/>
+          <p:cNvPr id="25" name="TextBox 24"/>
           <p:cNvSpPr txBox="1"/>
           <p:nvPr/>
         </p:nvSpPr>
         <p:spPr>
           <a:xfrm>
-            <a:off x="4572000" y="5029200"/>
-            <a:ext cx="3017520" cy="1097280"/>
+            <a:off x="3017520" y="5074920"/>
+            <a:ext cx="4114800" cy="411480"/>
           </a:xfrm>
           <a:prstGeom prst="rect">
             <a:avLst/>
@@ -9445,7 +9992,7 @@
           <a:lstStyle/>
           <a:p>
             <a:pPr algn="l">
-              <a:defRPr sz="1400" b="0">
+              <a:defRPr sz="1200" b="0">
                 <a:solidFill>
                   <a:srgbClr val="B3B3B3"/>
                 </a:solidFill>
@@ -9453,25 +10000,25 @@
               </a:defRPr>
             </a:pPr>
             <a:r>
-              <a:t>Detection de fraudes, trading algorithmique, evaluation des risques, chatbots de service client.</a:t>
-            </a:r>
-          </a:p>
-        </p:txBody>
-      </p:sp>
-      <p:sp>
-        <p:nvSpPr>
-          <p:cNvPr id="20" name="Rounded Rectangle 19"/>
+              <a:t>Detection de fraude bancaire, trading automatique, chatbots</a:t>
+            </a:r>
+          </a:p>
+        </p:txBody>
+      </p:sp>
+      <p:sp>
+        <p:nvSpPr>
+          <p:cNvPr id="26" name="Rounded Rectangle 25"/>
           <p:cNvSpPr/>
           <p:nvPr/>
         </p:nvSpPr>
         <p:spPr>
           <a:xfrm>
-            <a:off x="8138160" y="4206240"/>
-            <a:ext cx="3566160" cy="2103120"/>
+            <a:off x="457200" y="5715000"/>
+            <a:ext cx="6858000" cy="658368"/>
           </a:xfrm>
           <a:prstGeom prst="roundRect">
             <a:avLst>
-              <a:gd name="adj" fmla="val 4000"/>
+              <a:gd name="adj" fmla="val 2000"/>
             </a:avLst>
           </a:prstGeom>
           <a:solidFill>
@@ -9505,14 +10052,57 @@
       </p:sp>
       <p:sp>
         <p:nvSpPr>
-          <p:cNvPr id="21" name="TextBox 20"/>
+          <p:cNvPr id="27" name="Oval 26"/>
+          <p:cNvSpPr/>
+          <p:nvPr/>
+        </p:nvSpPr>
+        <p:spPr>
+          <a:xfrm>
+            <a:off x="731520" y="5897880"/>
+            <a:ext cx="292608" cy="292608"/>
+          </a:xfrm>
+          <a:prstGeom prst="ellipse">
+            <a:avLst/>
+          </a:prstGeom>
+          <a:solidFill>
+            <a:srgbClr val="818CF8"/>
+          </a:solidFill>
+          <a:ln>
+            <a:noFill/>
+          </a:ln>
+        </p:spPr>
+        <p:style>
+          <a:lnRef idx="1">
+            <a:schemeClr val="accent1"/>
+          </a:lnRef>
+          <a:fillRef idx="3">
+            <a:schemeClr val="accent1"/>
+          </a:fillRef>
+          <a:effectRef idx="2">
+            <a:schemeClr val="accent1"/>
+          </a:effectRef>
+          <a:fontRef idx="minor">
+            <a:schemeClr val="lt1"/>
+          </a:fontRef>
+        </p:style>
+        <p:txBody>
+          <a:bodyPr rtlCol="0" anchor="ctr"/>
+          <a:lstStyle/>
+          <a:p>
+            <a:pPr algn="ctr"/>
+          </a:p>
+        </p:txBody>
+      </p:sp>
+      <p:sp>
+        <p:nvSpPr>
+          <p:cNvPr id="28" name="TextBox 27"/>
           <p:cNvSpPr txBox="1"/>
           <p:nvPr/>
         </p:nvSpPr>
         <p:spPr>
           <a:xfrm>
-            <a:off x="8412480" y="4480560"/>
-            <a:ext cx="3017520" cy="457200"/>
+            <a:off x="1188720" y="5806440"/>
+            <a:ext cx="1828800" cy="457200"/>
           </a:xfrm>
           <a:prstGeom prst="rect">
             <a:avLst/>
@@ -9526,7 +10116,7 @@
           <a:lstStyle/>
           <a:p>
             <a:pPr algn="l">
-              <a:defRPr sz="2000" b="1">
+              <a:defRPr sz="1500" b="1">
                 <a:solidFill>
                   <a:srgbClr val="C084FC"/>
                 </a:solidFill>
@@ -9541,14 +10131,14 @@
       </p:sp>
       <p:sp>
         <p:nvSpPr>
-          <p:cNvPr id="22" name="TextBox 21"/>
+          <p:cNvPr id="29" name="TextBox 28"/>
           <p:cNvSpPr txBox="1"/>
           <p:nvPr/>
         </p:nvSpPr>
         <p:spPr>
           <a:xfrm>
-            <a:off x="8412480" y="5029200"/>
-            <a:ext cx="3017520" cy="1097280"/>
+            <a:off x="3017520" y="5852160"/>
+            <a:ext cx="4114800" cy="411480"/>
           </a:xfrm>
           <a:prstGeom prst="rect">
             <a:avLst/>
@@ -9562,7 +10152,7 @@
           <a:lstStyle/>
           <a:p>
             <a:pPr algn="l">
-              <a:defRPr sz="1400" b="0">
+              <a:defRPr sz="1200" b="0">
                 <a:solidFill>
                   <a:srgbClr val="B3B3B3"/>
                 </a:solidFill>
@@ -9570,7 +10160,7 @@
               </a:defRPr>
             </a:pPr>
             <a:r>
-              <a:t>Prevision climatique, surveillance de la deforestation, optimisation energetique, agriculture de precision.</a:t>
+              <a:t>Prevision meteo, detection incendies, agriculture par drones</a:t>
             </a:r>
           </a:p>
         </p:txBody>
@@ -9716,16 +10306,40 @@
           </a:p>
         </p:txBody>
       </p:sp>
-      <p:sp>
-        <p:nvSpPr>
-          <p:cNvPr id="5" name="Rounded Rectangle 4"/>
+      <p:pic>
+        <p:nvPicPr>
+          <p:cNvPr id="5" name="Picture 4" descr="ai-phone.jpg"/>
+          <p:cNvPicPr>
+            <a:picLocks noChangeAspect="1"/>
+          </p:cNvPicPr>
+          <p:nvPr/>
+        </p:nvPicPr>
+        <p:blipFill>
+          <a:blip r:embed="rId2"/>
+          <a:stretch>
+            <a:fillRect/>
+          </a:stretch>
+        </p:blipFill>
+        <p:spPr>
+          <a:xfrm>
+            <a:off x="8046720" y="1828800"/>
+            <a:ext cx="3657600" cy="2438400"/>
+          </a:xfrm>
+          <a:prstGeom prst="rect">
+            <a:avLst/>
+          </a:prstGeom>
+        </p:spPr>
+      </p:pic>
+      <p:sp>
+        <p:nvSpPr>
+          <p:cNvPr id="6" name="Rounded Rectangle 5"/>
           <p:cNvSpPr/>
           <p:nvPr/>
         </p:nvSpPr>
         <p:spPr>
           <a:xfrm>
-            <a:off x="731520" y="1828800"/>
-            <a:ext cx="10698480" cy="658368"/>
+            <a:off x="548640" y="1828800"/>
+            <a:ext cx="7132320" cy="658368"/>
           </a:xfrm>
           <a:prstGeom prst="roundRect">
             <a:avLst>
@@ -9763,13 +10377,13 @@
       </p:sp>
       <p:sp>
         <p:nvSpPr>
-          <p:cNvPr id="6" name="Oval 5"/>
+          <p:cNvPr id="7" name="Oval 6"/>
           <p:cNvSpPr/>
           <p:nvPr/>
         </p:nvSpPr>
         <p:spPr>
           <a:xfrm>
-            <a:off x="1097280" y="2029968"/>
+            <a:off x="822960" y="2029968"/>
             <a:ext cx="256032" cy="256032"/>
           </a:xfrm>
           <a:prstGeom prst="ellipse">
@@ -9806,14 +10420,14 @@
       </p:sp>
       <p:sp>
         <p:nvSpPr>
-          <p:cNvPr id="7" name="TextBox 6"/>
+          <p:cNvPr id="8" name="TextBox 7"/>
           <p:cNvSpPr txBox="1"/>
           <p:nvPr/>
         </p:nvSpPr>
         <p:spPr>
           <a:xfrm>
-            <a:off x="1554480" y="1965960"/>
-            <a:ext cx="2286000" cy="411480"/>
+            <a:off x="1280160" y="1938528"/>
+            <a:ext cx="2286000" cy="457200"/>
           </a:xfrm>
           <a:prstGeom prst="rect">
             <a:avLst/>
@@ -9827,7 +10441,7 @@
           <a:lstStyle/>
           <a:p>
             <a:pPr algn="l">
-              <a:defRPr sz="1600" b="1">
+              <a:defRPr sz="1500" b="1">
                 <a:solidFill>
                   <a:srgbClr val="C084FC"/>
                 </a:solidFill>
@@ -9842,14 +10456,14 @@
       </p:sp>
       <p:sp>
         <p:nvSpPr>
-          <p:cNvPr id="8" name="TextBox 7"/>
+          <p:cNvPr id="9" name="TextBox 8"/>
           <p:cNvSpPr txBox="1"/>
           <p:nvPr/>
         </p:nvSpPr>
         <p:spPr>
           <a:xfrm>
-            <a:off x="3840480" y="1965960"/>
-            <a:ext cx="7315200" cy="411480"/>
+            <a:off x="3566160" y="1965960"/>
+            <a:ext cx="3931920" cy="411480"/>
           </a:xfrm>
           <a:prstGeom prst="rect">
             <a:avLst/>
@@ -9863,7 +10477,7 @@
           <a:lstStyle/>
           <a:p>
             <a:pPr algn="l">
-              <a:defRPr sz="1500" b="0">
+              <a:defRPr sz="1300" b="0">
                 <a:solidFill>
                   <a:srgbClr val="B3B3B3"/>
                 </a:solidFill>
@@ -9871,21 +10485,21 @@
               </a:defRPr>
             </a:pPr>
             <a:r>
-              <a:t>Siri, Google Assistant, Alexa comprennent et repondent a vos questions</a:t>
-            </a:r>
-          </a:p>
-        </p:txBody>
-      </p:sp>
-      <p:sp>
-        <p:nvSpPr>
-          <p:cNvPr id="9" name="Rounded Rectangle 8"/>
+              <a:t>Siri, Google Assistant, Alexa - posez une question, l'IA repond</a:t>
+            </a:r>
+          </a:p>
+        </p:txBody>
+      </p:sp>
+      <p:sp>
+        <p:nvSpPr>
+          <p:cNvPr id="10" name="Rounded Rectangle 9"/>
           <p:cNvSpPr/>
           <p:nvPr/>
         </p:nvSpPr>
         <p:spPr>
           <a:xfrm>
-            <a:off x="731520" y="2606040"/>
-            <a:ext cx="10698480" cy="658368"/>
+            <a:off x="548640" y="2606040"/>
+            <a:ext cx="7132320" cy="658368"/>
           </a:xfrm>
           <a:prstGeom prst="roundRect">
             <a:avLst>
@@ -9923,13 +10537,13 @@
       </p:sp>
       <p:sp>
         <p:nvSpPr>
-          <p:cNvPr id="10" name="Oval 9"/>
+          <p:cNvPr id="11" name="Oval 10"/>
           <p:cNvSpPr/>
           <p:nvPr/>
         </p:nvSpPr>
         <p:spPr>
           <a:xfrm>
-            <a:off x="1097280" y="2807208"/>
+            <a:off x="822960" y="2807208"/>
             <a:ext cx="256032" cy="256032"/>
           </a:xfrm>
           <a:prstGeom prst="ellipse">
@@ -9966,14 +10580,14 @@
       </p:sp>
       <p:sp>
         <p:nvSpPr>
-          <p:cNvPr id="11" name="TextBox 10"/>
+          <p:cNvPr id="12" name="TextBox 11"/>
           <p:cNvSpPr txBox="1"/>
           <p:nvPr/>
         </p:nvSpPr>
         <p:spPr>
           <a:xfrm>
-            <a:off x="1554480" y="2743200"/>
-            <a:ext cx="2286000" cy="411480"/>
+            <a:off x="1280160" y="2715768"/>
+            <a:ext cx="2286000" cy="457200"/>
           </a:xfrm>
           <a:prstGeom prst="rect">
             <a:avLst/>
@@ -9987,7 +10601,7 @@
           <a:lstStyle/>
           <a:p>
             <a:pPr algn="l">
-              <a:defRPr sz="1600" b="1">
+              <a:defRPr sz="1500" b="1">
                 <a:solidFill>
                   <a:srgbClr val="C084FC"/>
                 </a:solidFill>
@@ -10002,14 +10616,14 @@
       </p:sp>
       <p:sp>
         <p:nvSpPr>
-          <p:cNvPr id="12" name="TextBox 11"/>
+          <p:cNvPr id="13" name="TextBox 12"/>
           <p:cNvSpPr txBox="1"/>
           <p:nvPr/>
         </p:nvSpPr>
         <p:spPr>
           <a:xfrm>
-            <a:off x="3840480" y="2743200"/>
-            <a:ext cx="7315200" cy="411480"/>
+            <a:off x="3566160" y="2743200"/>
+            <a:ext cx="3931920" cy="411480"/>
           </a:xfrm>
           <a:prstGeom prst="rect">
             <a:avLst/>
@@ -10023,7 +10637,7 @@
           <a:lstStyle/>
           <a:p>
             <a:pPr algn="l">
-              <a:defRPr sz="1500" b="0">
+              <a:defRPr sz="1300" b="0">
                 <a:solidFill>
                   <a:srgbClr val="B3B3B3"/>
                 </a:solidFill>
@@ -10031,21 +10645,21 @@
               </a:defRPr>
             </a:pPr>
             <a:r>
-              <a:t>L'IA selectionne le contenu de votre fil d'actualite (Instagram, TikTok, YouTube)</a:t>
-            </a:r>
-          </a:p>
-        </p:txBody>
-      </p:sp>
-      <p:sp>
-        <p:nvSpPr>
-          <p:cNvPr id="13" name="Rounded Rectangle 12"/>
+              <a:t>TikTok, Instagram, YouTube - l'IA choisit votre contenu</a:t>
+            </a:r>
+          </a:p>
+        </p:txBody>
+      </p:sp>
+      <p:sp>
+        <p:nvSpPr>
+          <p:cNvPr id="14" name="Rounded Rectangle 13"/>
           <p:cNvSpPr/>
           <p:nvPr/>
         </p:nvSpPr>
         <p:spPr>
           <a:xfrm>
-            <a:off x="731520" y="3383280"/>
-            <a:ext cx="10698480" cy="658368"/>
+            <a:off x="548640" y="3383280"/>
+            <a:ext cx="7132320" cy="658368"/>
           </a:xfrm>
           <a:prstGeom prst="roundRect">
             <a:avLst>
@@ -10083,13 +10697,13 @@
       </p:sp>
       <p:sp>
         <p:nvSpPr>
-          <p:cNvPr id="14" name="Oval 13"/>
+          <p:cNvPr id="15" name="Oval 14"/>
           <p:cNvSpPr/>
           <p:nvPr/>
         </p:nvSpPr>
         <p:spPr>
           <a:xfrm>
-            <a:off x="1097280" y="3584448"/>
+            <a:off x="822960" y="3584448"/>
             <a:ext cx="256032" cy="256032"/>
           </a:xfrm>
           <a:prstGeom prst="ellipse">
@@ -10126,14 +10740,14 @@
       </p:sp>
       <p:sp>
         <p:nvSpPr>
-          <p:cNvPr id="15" name="TextBox 14"/>
+          <p:cNvPr id="16" name="TextBox 15"/>
           <p:cNvSpPr txBox="1"/>
           <p:nvPr/>
         </p:nvSpPr>
         <p:spPr>
           <a:xfrm>
-            <a:off x="1554480" y="3520440"/>
-            <a:ext cx="2286000" cy="411480"/>
+            <a:off x="1280160" y="3493008"/>
+            <a:ext cx="2286000" cy="457200"/>
           </a:xfrm>
           <a:prstGeom prst="rect">
             <a:avLst/>
@@ -10147,7 +10761,7 @@
           <a:lstStyle/>
           <a:p>
             <a:pPr algn="l">
-              <a:defRPr sz="1600" b="1">
+              <a:defRPr sz="1500" b="1">
                 <a:solidFill>
                   <a:srgbClr val="C084FC"/>
                 </a:solidFill>
@@ -10162,14 +10776,14 @@
       </p:sp>
       <p:sp>
         <p:nvSpPr>
-          <p:cNvPr id="16" name="TextBox 15"/>
+          <p:cNvPr id="17" name="TextBox 16"/>
           <p:cNvSpPr txBox="1"/>
           <p:nvPr/>
         </p:nvSpPr>
         <p:spPr>
           <a:xfrm>
-            <a:off x="3840480" y="3520440"/>
-            <a:ext cx="7315200" cy="411480"/>
+            <a:off x="3566160" y="3520440"/>
+            <a:ext cx="3931920" cy="411480"/>
           </a:xfrm>
           <a:prstGeom prst="rect">
             <a:avLst/>
@@ -10183,7 +10797,7 @@
           <a:lstStyle/>
           <a:p>
             <a:pPr algn="l">
-              <a:defRPr sz="1500" b="0">
+              <a:defRPr sz="1300" b="0">
                 <a:solidFill>
                   <a:srgbClr val="B3B3B3"/>
                 </a:solidFill>
@@ -10191,21 +10805,21 @@
               </a:defRPr>
             </a:pPr>
             <a:r>
-              <a:t>Netflix et Spotify utilisent l'IA pour recommander des films et de la musique</a:t>
-            </a:r>
-          </a:p>
-        </p:txBody>
-      </p:sp>
-      <p:sp>
-        <p:nvSpPr>
-          <p:cNvPr id="17" name="Rounded Rectangle 16"/>
+              <a:t>Netflix, Spotify - recommandations personnalisees</a:t>
+            </a:r>
+          </a:p>
+        </p:txBody>
+      </p:sp>
+      <p:sp>
+        <p:nvSpPr>
+          <p:cNvPr id="18" name="Rounded Rectangle 17"/>
           <p:cNvSpPr/>
           <p:nvPr/>
         </p:nvSpPr>
         <p:spPr>
           <a:xfrm>
-            <a:off x="731520" y="4160520"/>
-            <a:ext cx="10698480" cy="658368"/>
+            <a:off x="548640" y="4160520"/>
+            <a:ext cx="7132320" cy="658368"/>
           </a:xfrm>
           <a:prstGeom prst="roundRect">
             <a:avLst>
@@ -10243,13 +10857,13 @@
       </p:sp>
       <p:sp>
         <p:nvSpPr>
-          <p:cNvPr id="18" name="Oval 17"/>
+          <p:cNvPr id="19" name="Oval 18"/>
           <p:cNvSpPr/>
           <p:nvPr/>
         </p:nvSpPr>
         <p:spPr>
           <a:xfrm>
-            <a:off x="1097280" y="4361688"/>
+            <a:off x="822960" y="4361688"/>
             <a:ext cx="256032" cy="256032"/>
           </a:xfrm>
           <a:prstGeom prst="ellipse">
@@ -10286,14 +10900,14 @@
       </p:sp>
       <p:sp>
         <p:nvSpPr>
-          <p:cNvPr id="19" name="TextBox 18"/>
+          <p:cNvPr id="20" name="TextBox 19"/>
           <p:cNvSpPr txBox="1"/>
           <p:nvPr/>
         </p:nvSpPr>
         <p:spPr>
           <a:xfrm>
-            <a:off x="1554480" y="4297680"/>
-            <a:ext cx="2286000" cy="411480"/>
+            <a:off x="1280160" y="4270248"/>
+            <a:ext cx="2286000" cy="457200"/>
           </a:xfrm>
           <a:prstGeom prst="rect">
             <a:avLst/>
@@ -10307,7 +10921,7 @@
           <a:lstStyle/>
           <a:p>
             <a:pPr algn="l">
-              <a:defRPr sz="1600" b="1">
+              <a:defRPr sz="1500" b="1">
                 <a:solidFill>
                   <a:srgbClr val="C084FC"/>
                 </a:solidFill>
@@ -10315,21 +10929,21 @@
               </a:defRPr>
             </a:pPr>
             <a:r>
-              <a:t>Photographie</a:t>
-            </a:r>
-          </a:p>
-        </p:txBody>
-      </p:sp>
-      <p:sp>
-        <p:nvSpPr>
-          <p:cNvPr id="20" name="TextBox 19"/>
+              <a:t>Photo/Video</a:t>
+            </a:r>
+          </a:p>
+        </p:txBody>
+      </p:sp>
+      <p:sp>
+        <p:nvSpPr>
+          <p:cNvPr id="21" name="TextBox 20"/>
           <p:cNvSpPr txBox="1"/>
           <p:nvPr/>
         </p:nvSpPr>
         <p:spPr>
           <a:xfrm>
-            <a:off x="3840480" y="4297680"/>
-            <a:ext cx="7315200" cy="411480"/>
+            <a:off x="3566160" y="4297680"/>
+            <a:ext cx="3931920" cy="411480"/>
           </a:xfrm>
           <a:prstGeom prst="rect">
             <a:avLst/>
@@ -10343,7 +10957,7 @@
           <a:lstStyle/>
           <a:p>
             <a:pPr algn="l">
-              <a:defRPr sz="1500" b="0">
+              <a:defRPr sz="1300" b="0">
                 <a:solidFill>
                   <a:srgbClr val="B3B3B3"/>
                 </a:solidFill>
@@ -10351,21 +10965,21 @@
               </a:defRPr>
             </a:pPr>
             <a:r>
-              <a:t>Le mode portrait et les filtres de votre telephone utilisent l'IA</a:t>
-            </a:r>
-          </a:p>
-        </p:txBody>
-      </p:sp>
-      <p:sp>
-        <p:nvSpPr>
-          <p:cNvPr id="21" name="Rounded Rectangle 20"/>
+              <a:t>Mode portrait, filtres Snapchat, retouche automatique</a:t>
+            </a:r>
+          </a:p>
+        </p:txBody>
+      </p:sp>
+      <p:sp>
+        <p:nvSpPr>
+          <p:cNvPr id="22" name="Rounded Rectangle 21"/>
           <p:cNvSpPr/>
           <p:nvPr/>
         </p:nvSpPr>
         <p:spPr>
           <a:xfrm>
-            <a:off x="731520" y="4937760"/>
-            <a:ext cx="10698480" cy="658368"/>
+            <a:off x="548640" y="4937760"/>
+            <a:ext cx="7132320" cy="658368"/>
           </a:xfrm>
           <a:prstGeom prst="roundRect">
             <a:avLst>
@@ -10403,13 +11017,13 @@
       </p:sp>
       <p:sp>
         <p:nvSpPr>
-          <p:cNvPr id="22" name="Oval 21"/>
+          <p:cNvPr id="23" name="Oval 22"/>
           <p:cNvSpPr/>
           <p:nvPr/>
         </p:nvSpPr>
         <p:spPr>
           <a:xfrm>
-            <a:off x="1097280" y="5138928"/>
+            <a:off x="822960" y="5138928"/>
             <a:ext cx="256032" cy="256032"/>
           </a:xfrm>
           <a:prstGeom prst="ellipse">
@@ -10446,14 +11060,14 @@
       </p:sp>
       <p:sp>
         <p:nvSpPr>
-          <p:cNvPr id="23" name="TextBox 22"/>
+          <p:cNvPr id="24" name="TextBox 23"/>
           <p:cNvSpPr txBox="1"/>
           <p:nvPr/>
         </p:nvSpPr>
         <p:spPr>
           <a:xfrm>
-            <a:off x="1554480" y="5074920"/>
-            <a:ext cx="2286000" cy="411480"/>
+            <a:off x="1280160" y="5047488"/>
+            <a:ext cx="2286000" cy="457200"/>
           </a:xfrm>
           <a:prstGeom prst="rect">
             <a:avLst/>
@@ -10467,7 +11081,7 @@
           <a:lstStyle/>
           <a:p>
             <a:pPr algn="l">
-              <a:defRPr sz="1600" b="1">
+              <a:defRPr sz="1500" b="1">
                 <a:solidFill>
                   <a:srgbClr val="C084FC"/>
                 </a:solidFill>
@@ -10482,14 +11096,14 @@
       </p:sp>
       <p:sp>
         <p:nvSpPr>
-          <p:cNvPr id="24" name="TextBox 23"/>
+          <p:cNvPr id="25" name="TextBox 24"/>
           <p:cNvSpPr txBox="1"/>
           <p:nvPr/>
         </p:nvSpPr>
         <p:spPr>
           <a:xfrm>
-            <a:off x="3840480" y="5074920"/>
-            <a:ext cx="7315200" cy="411480"/>
+            <a:off x="3566160" y="5074920"/>
+            <a:ext cx="3931920" cy="411480"/>
           </a:xfrm>
           <a:prstGeom prst="rect">
             <a:avLst/>
@@ -10503,7 +11117,7 @@
           <a:lstStyle/>
           <a:p>
             <a:pPr algn="l">
-              <a:defRPr sz="1500" b="0">
+              <a:defRPr sz="1300" b="0">
                 <a:solidFill>
                   <a:srgbClr val="B3B3B3"/>
                 </a:solidFill>
@@ -10511,21 +11125,21 @@
               </a:defRPr>
             </a:pPr>
             <a:r>
-              <a:t>Google Translate utilise l'IA pour traduire plus de 100 langues</a:t>
-            </a:r>
-          </a:p>
-        </p:txBody>
-      </p:sp>
-      <p:sp>
-        <p:nvSpPr>
-          <p:cNvPr id="25" name="Rounded Rectangle 24"/>
+              <a:t>Google Translate - 100+ langues en temps reel</a:t>
+            </a:r>
+          </a:p>
+        </p:txBody>
+      </p:sp>
+      <p:sp>
+        <p:nvSpPr>
+          <p:cNvPr id="26" name="Rounded Rectangle 25"/>
           <p:cNvSpPr/>
           <p:nvPr/>
         </p:nvSpPr>
         <p:spPr>
           <a:xfrm>
-            <a:off x="731520" y="5715000"/>
-            <a:ext cx="10698480" cy="658368"/>
+            <a:off x="548640" y="5715000"/>
+            <a:ext cx="7132320" cy="658368"/>
           </a:xfrm>
           <a:prstGeom prst="roundRect">
             <a:avLst>
@@ -10563,13 +11177,13 @@
       </p:sp>
       <p:sp>
         <p:nvSpPr>
-          <p:cNvPr id="26" name="Oval 25"/>
+          <p:cNvPr id="27" name="Oval 26"/>
           <p:cNvSpPr/>
           <p:nvPr/>
         </p:nvSpPr>
         <p:spPr>
           <a:xfrm>
-            <a:off x="1097280" y="5916168"/>
+            <a:off x="822960" y="5916168"/>
             <a:ext cx="256032" cy="256032"/>
           </a:xfrm>
           <a:prstGeom prst="ellipse">
@@ -10606,14 +11220,14 @@
       </p:sp>
       <p:sp>
         <p:nvSpPr>
-          <p:cNvPr id="27" name="TextBox 26"/>
+          <p:cNvPr id="28" name="TextBox 27"/>
           <p:cNvSpPr txBox="1"/>
           <p:nvPr/>
         </p:nvSpPr>
         <p:spPr>
           <a:xfrm>
-            <a:off x="1554480" y="5852160"/>
-            <a:ext cx="2286000" cy="411480"/>
+            <a:off x="1280160" y="5824728"/>
+            <a:ext cx="2286000" cy="457200"/>
           </a:xfrm>
           <a:prstGeom prst="rect">
             <a:avLst/>
@@ -10627,7 +11241,7 @@
           <a:lstStyle/>
           <a:p>
             <a:pPr algn="l">
-              <a:defRPr sz="1600" b="1">
+              <a:defRPr sz="1500" b="1">
                 <a:solidFill>
                   <a:srgbClr val="C084FC"/>
                 </a:solidFill>
@@ -10635,21 +11249,21 @@
               </a:defRPr>
             </a:pPr>
             <a:r>
-              <a:t>ChatGPT</a:t>
-            </a:r>
-          </a:p>
-        </p:txBody>
-      </p:sp>
-      <p:sp>
-        <p:nvSpPr>
-          <p:cNvPr id="28" name="TextBox 27"/>
+              <a:t>IA Generative</a:t>
+            </a:r>
+          </a:p>
+        </p:txBody>
+      </p:sp>
+      <p:sp>
+        <p:nvSpPr>
+          <p:cNvPr id="29" name="TextBox 28"/>
           <p:cNvSpPr txBox="1"/>
           <p:nvPr/>
         </p:nvSpPr>
         <p:spPr>
           <a:xfrm>
-            <a:off x="3840480" y="5852160"/>
-            <a:ext cx="7315200" cy="411480"/>
+            <a:off x="3566160" y="5852160"/>
+            <a:ext cx="3931920" cy="411480"/>
           </a:xfrm>
           <a:prstGeom prst="rect">
             <a:avLst/>
@@ -10663,7 +11277,7 @@
           <a:lstStyle/>
           <a:p>
             <a:pPr algn="l">
-              <a:defRPr sz="1500" b="0">
+              <a:defRPr sz="1300" b="0">
                 <a:solidFill>
                   <a:srgbClr val="B3B3B3"/>
                 </a:solidFill>
@@ -10671,7 +11285,7 @@
               </a:defRPr>
             </a:pPr>
             <a:r>
-              <a:t>Des millions de personnes utilisent l'IA generative pour ecrire, coder et creer</a:t>
+              <a:t>ChatGPT, DALL-E, Midjourney - creation de texte et images</a:t>
             </a:r>
           </a:p>
         </p:txBody>
@@ -10825,7 +11439,7 @@
         </p:nvSpPr>
         <p:spPr>
           <a:xfrm>
-            <a:off x="548640" y="1828800"/>
+            <a:off x="457200" y="1828800"/>
             <a:ext cx="5303520" cy="4572000"/>
           </a:xfrm>
           <a:prstGeom prst="roundRect">
@@ -10864,14 +11478,59 @@
       </p:sp>
       <p:sp>
         <p:nvSpPr>
-          <p:cNvPr id="6" name="TextBox 5"/>
+          <p:cNvPr id="6" name="Rounded Rectangle 5"/>
+          <p:cNvSpPr/>
+          <p:nvPr/>
+        </p:nvSpPr>
+        <p:spPr>
+          <a:xfrm>
+            <a:off x="457200" y="1828800"/>
+            <a:ext cx="5303520" cy="548640"/>
+          </a:xfrm>
+          <a:prstGeom prst="roundRect">
+            <a:avLst>
+              <a:gd name="adj" fmla="val 4000"/>
+            </a:avLst>
+          </a:prstGeom>
+          <a:solidFill>
+            <a:srgbClr val="34D399"/>
+          </a:solidFill>
+          <a:ln>
+            <a:noFill/>
+          </a:ln>
+        </p:spPr>
+        <p:style>
+          <a:lnRef idx="1">
+            <a:schemeClr val="accent1"/>
+          </a:lnRef>
+          <a:fillRef idx="3">
+            <a:schemeClr val="accent1"/>
+          </a:fillRef>
+          <a:effectRef idx="2">
+            <a:schemeClr val="accent1"/>
+          </a:effectRef>
+          <a:fontRef idx="minor">
+            <a:schemeClr val="lt1"/>
+          </a:fontRef>
+        </p:style>
+        <p:txBody>
+          <a:bodyPr rtlCol="0" anchor="ctr"/>
+          <a:lstStyle/>
+          <a:p>
+            <a:pPr algn="ctr"/>
+          </a:p>
+        </p:txBody>
+      </p:sp>
+      <p:sp>
+        <p:nvSpPr>
+          <p:cNvPr id="7" name="TextBox 6"/>
           <p:cNvSpPr txBox="1"/>
           <p:nvPr/>
         </p:nvSpPr>
         <p:spPr>
           <a:xfrm>
-            <a:off x="914400" y="2011680"/>
-            <a:ext cx="4572000" cy="548640"/>
+            <a:off x="731520" y="1874519"/>
+            <a:ext cx="4754880" cy="457200"/>
           </a:xfrm>
           <a:prstGeom prst="rect">
             <a:avLst/>
@@ -10884,29 +11543,29 @@
           </a:bodyPr>
           <a:lstStyle/>
           <a:p>
-            <a:pPr algn="l">
-              <a:defRPr sz="2400" b="1">
-                <a:solidFill>
-                  <a:srgbClr val="34D399"/>
-                </a:solidFill>
-                <a:latin typeface="Calibri"/>
-              </a:defRPr>
-            </a:pPr>
-            <a:r>
-              <a:t>Avantages</a:t>
-            </a:r>
-          </a:p>
-        </p:txBody>
-      </p:sp>
-      <p:sp>
-        <p:nvSpPr>
-          <p:cNvPr id="7" name="TextBox 6"/>
+            <a:pPr algn="ctr">
+              <a:defRPr sz="2000" b="1">
+                <a:solidFill>
+                  <a:srgbClr val="FFFFFF"/>
+                </a:solidFill>
+                <a:latin typeface="Calibri"/>
+              </a:defRPr>
+            </a:pPr>
+            <a:r>
+              <a:t>AVANTAGES</a:t>
+            </a:r>
+          </a:p>
+        </p:txBody>
+      </p:sp>
+      <p:sp>
+        <p:nvSpPr>
+          <p:cNvPr id="8" name="TextBox 7"/>
           <p:cNvSpPr txBox="1"/>
           <p:nvPr/>
         </p:nvSpPr>
         <p:spPr>
           <a:xfrm>
-            <a:off x="914400" y="2743200"/>
+            <a:off x="822960" y="2560320"/>
             <a:ext cx="4754880" cy="457200"/>
           </a:xfrm>
           <a:prstGeom prst="rect">
@@ -10929,20 +11588,20 @@
               </a:defRPr>
             </a:pPr>
             <a:r>
-              <a:t>+ Automatisation des taches repetitives et ennuyeuses</a:t>
-            </a:r>
-          </a:p>
-        </p:txBody>
-      </p:sp>
-      <p:sp>
-        <p:nvSpPr>
-          <p:cNvPr id="8" name="TextBox 7"/>
+              <a:t>+ Automatisation des taches repetitives</a:t>
+            </a:r>
+          </a:p>
+        </p:txBody>
+      </p:sp>
+      <p:sp>
+        <p:nvSpPr>
+          <p:cNvPr id="9" name="TextBox 8"/>
           <p:cNvSpPr txBox="1"/>
           <p:nvPr/>
         </p:nvSpPr>
         <p:spPr>
           <a:xfrm>
-            <a:off x="914400" y="3291840"/>
+            <a:off x="822960" y="3154680"/>
             <a:ext cx="4754880" cy="457200"/>
           </a:xfrm>
           <a:prstGeom prst="rect">
@@ -10965,20 +11624,20 @@
               </a:defRPr>
             </a:pPr>
             <a:r>
-              <a:t>+ Analyse rapide de grandes quantites de donnees</a:t>
-            </a:r>
-          </a:p>
-        </p:txBody>
-      </p:sp>
-      <p:sp>
-        <p:nvSpPr>
-          <p:cNvPr id="9" name="TextBox 8"/>
+              <a:t>+ Analyse de donnees ultra-rapide</a:t>
+            </a:r>
+          </a:p>
+        </p:txBody>
+      </p:sp>
+      <p:sp>
+        <p:nvSpPr>
+          <p:cNvPr id="10" name="TextBox 9"/>
           <p:cNvSpPr txBox="1"/>
           <p:nvPr/>
         </p:nvSpPr>
         <p:spPr>
           <a:xfrm>
-            <a:off x="914400" y="3840480"/>
+            <a:off x="822960" y="3749040"/>
             <a:ext cx="4754880" cy="457200"/>
           </a:xfrm>
           <a:prstGeom prst="rect">
@@ -11001,20 +11660,20 @@
               </a:defRPr>
             </a:pPr>
             <a:r>
-              <a:t>+ Disponible 24h/24, 7j/7 sans fatigue</a:t>
-            </a:r>
-          </a:p>
-        </p:txBody>
-      </p:sp>
-      <p:sp>
-        <p:nvSpPr>
-          <p:cNvPr id="10" name="TextBox 9"/>
+              <a:t>+ Disponible 24h/24, jamais fatigue</a:t>
+            </a:r>
+          </a:p>
+        </p:txBody>
+      </p:sp>
+      <p:sp>
+        <p:nvSpPr>
+          <p:cNvPr id="11" name="TextBox 10"/>
           <p:cNvSpPr txBox="1"/>
           <p:nvPr/>
         </p:nvSpPr>
         <p:spPr>
           <a:xfrm>
-            <a:off x="914400" y="4389120"/>
+            <a:off x="822960" y="4343400"/>
             <a:ext cx="4754880" cy="457200"/>
           </a:xfrm>
           <a:prstGeom prst="rect">
@@ -11037,20 +11696,20 @@
               </a:defRPr>
             </a:pPr>
             <a:r>
-              <a:t>+ Amelioration des diagnostics medicaux</a:t>
-            </a:r>
-          </a:p>
-        </p:txBody>
-      </p:sp>
-      <p:sp>
-        <p:nvSpPr>
-          <p:cNvPr id="11" name="TextBox 10"/>
+              <a:t>+ Diagnostics medicaux plus precis</a:t>
+            </a:r>
+          </a:p>
+        </p:txBody>
+      </p:sp>
+      <p:sp>
+        <p:nvSpPr>
+          <p:cNvPr id="12" name="TextBox 11"/>
           <p:cNvSpPr txBox="1"/>
           <p:nvPr/>
         </p:nvSpPr>
         <p:spPr>
           <a:xfrm>
-            <a:off x="914400" y="4937760"/>
+            <a:off x="822960" y="4937760"/>
             <a:ext cx="4754880" cy="457200"/>
           </a:xfrm>
           <a:prstGeom prst="rect">
@@ -11080,13 +11739,13 @@
       </p:sp>
       <p:sp>
         <p:nvSpPr>
-          <p:cNvPr id="12" name="TextBox 11"/>
+          <p:cNvPr id="13" name="TextBox 12"/>
           <p:cNvSpPr txBox="1"/>
           <p:nvPr/>
         </p:nvSpPr>
         <p:spPr>
           <a:xfrm>
-            <a:off x="914400" y="5486400"/>
+            <a:off x="822960" y="5532120"/>
             <a:ext cx="4754880" cy="457200"/>
           </a:xfrm>
           <a:prstGeom prst="rect">
@@ -11109,20 +11768,20 @@
               </a:defRPr>
             </a:pPr>
             <a:r>
-              <a:t>+ Innovation dans tous les domaines scientifiques</a:t>
-            </a:r>
-          </a:p>
-        </p:txBody>
-      </p:sp>
-      <p:sp>
-        <p:nvSpPr>
-          <p:cNvPr id="13" name="Rounded Rectangle 12"/>
+              <a:t>+ Innovation scientifique acceleree</a:t>
+            </a:r>
+          </a:p>
+        </p:txBody>
+      </p:sp>
+      <p:sp>
+        <p:nvSpPr>
+          <p:cNvPr id="14" name="Rounded Rectangle 13"/>
           <p:cNvSpPr/>
           <p:nvPr/>
         </p:nvSpPr>
         <p:spPr>
           <a:xfrm>
-            <a:off x="6309360" y="1828800"/>
+            <a:off x="6400800" y="1828800"/>
             <a:ext cx="5303520" cy="4572000"/>
           </a:xfrm>
           <a:prstGeom prst="roundRect">
@@ -11161,14 +11820,59 @@
       </p:sp>
       <p:sp>
         <p:nvSpPr>
-          <p:cNvPr id="14" name="TextBox 13"/>
+          <p:cNvPr id="15" name="Rounded Rectangle 14"/>
+          <p:cNvSpPr/>
+          <p:nvPr/>
+        </p:nvSpPr>
+        <p:spPr>
+          <a:xfrm>
+            <a:off x="6400800" y="1828800"/>
+            <a:ext cx="5303520" cy="548640"/>
+          </a:xfrm>
+          <a:prstGeom prst="roundRect">
+            <a:avLst>
+              <a:gd name="adj" fmla="val 4000"/>
+            </a:avLst>
+          </a:prstGeom>
+          <a:solidFill>
+            <a:srgbClr val="F87171"/>
+          </a:solidFill>
+          <a:ln>
+            <a:noFill/>
+          </a:ln>
+        </p:spPr>
+        <p:style>
+          <a:lnRef idx="1">
+            <a:schemeClr val="accent1"/>
+          </a:lnRef>
+          <a:fillRef idx="3">
+            <a:schemeClr val="accent1"/>
+          </a:fillRef>
+          <a:effectRef idx="2">
+            <a:schemeClr val="accent1"/>
+          </a:effectRef>
+          <a:fontRef idx="minor">
+            <a:schemeClr val="lt1"/>
+          </a:fontRef>
+        </p:style>
+        <p:txBody>
+          <a:bodyPr rtlCol="0" anchor="ctr"/>
+          <a:lstStyle/>
+          <a:p>
+            <a:pPr algn="ctr"/>
+          </a:p>
+        </p:txBody>
+      </p:sp>
+      <p:sp>
+        <p:nvSpPr>
+          <p:cNvPr id="16" name="TextBox 15"/>
           <p:cNvSpPr txBox="1"/>
           <p:nvPr/>
         </p:nvSpPr>
         <p:spPr>
           <a:xfrm>
-            <a:off x="6675120" y="2011680"/>
-            <a:ext cx="4572000" cy="548640"/>
+            <a:off x="6675120" y="1874519"/>
+            <a:ext cx="4754880" cy="457200"/>
           </a:xfrm>
           <a:prstGeom prst="rect">
             <a:avLst/>
@@ -11181,29 +11885,29 @@
           </a:bodyPr>
           <a:lstStyle/>
           <a:p>
-            <a:pPr algn="l">
-              <a:defRPr sz="2400" b="1">
-                <a:solidFill>
-                  <a:srgbClr val="F87171"/>
-                </a:solidFill>
-                <a:latin typeface="Calibri"/>
-              </a:defRPr>
-            </a:pPr>
-            <a:r>
-              <a:t>Inconvenients</a:t>
-            </a:r>
-          </a:p>
-        </p:txBody>
-      </p:sp>
-      <p:sp>
-        <p:nvSpPr>
-          <p:cNvPr id="15" name="TextBox 14"/>
+            <a:pPr algn="ctr">
+              <a:defRPr sz="2000" b="1">
+                <a:solidFill>
+                  <a:srgbClr val="FFFFFF"/>
+                </a:solidFill>
+                <a:latin typeface="Calibri"/>
+              </a:defRPr>
+            </a:pPr>
+            <a:r>
+              <a:t>INCONVENIENTS</a:t>
+            </a:r>
+          </a:p>
+        </p:txBody>
+      </p:sp>
+      <p:sp>
+        <p:nvSpPr>
+          <p:cNvPr id="17" name="TextBox 16"/>
           <p:cNvSpPr txBox="1"/>
           <p:nvPr/>
         </p:nvSpPr>
         <p:spPr>
           <a:xfrm>
-            <a:off x="6675120" y="2743200"/>
+            <a:off x="6766560" y="2560320"/>
             <a:ext cx="4754880" cy="457200"/>
           </a:xfrm>
           <a:prstGeom prst="rect">
@@ -11226,20 +11930,20 @@
               </a:defRPr>
             </a:pPr>
             <a:r>
-              <a:t>- Risque de perte d'emplois (chomage technologique)</a:t>
-            </a:r>
-          </a:p>
-        </p:txBody>
-      </p:sp>
-      <p:sp>
-        <p:nvSpPr>
-          <p:cNvPr id="16" name="TextBox 15"/>
+              <a:t>- Perte d'emplois (chomage technologique)</a:t>
+            </a:r>
+          </a:p>
+        </p:txBody>
+      </p:sp>
+      <p:sp>
+        <p:nvSpPr>
+          <p:cNvPr id="18" name="TextBox 17"/>
           <p:cNvSpPr txBox="1"/>
           <p:nvPr/>
         </p:nvSpPr>
         <p:spPr>
           <a:xfrm>
-            <a:off x="6675120" y="3291840"/>
+            <a:off x="6766560" y="3154680"/>
             <a:ext cx="4754880" cy="457200"/>
           </a:xfrm>
           <a:prstGeom prst="rect">
@@ -11262,20 +11966,20 @@
               </a:defRPr>
             </a:pPr>
             <a:r>
-              <a:t>- Questions de vie privee et surveillance</a:t>
-            </a:r>
-          </a:p>
-        </p:txBody>
-      </p:sp>
-      <p:sp>
-        <p:nvSpPr>
-          <p:cNvPr id="17" name="TextBox 16"/>
+              <a:t>- Vie privee menacee (surveillance)</a:t>
+            </a:r>
+          </a:p>
+        </p:txBody>
+      </p:sp>
+      <p:sp>
+        <p:nvSpPr>
+          <p:cNvPr id="19" name="TextBox 18"/>
           <p:cNvSpPr txBox="1"/>
           <p:nvPr/>
         </p:nvSpPr>
         <p:spPr>
           <a:xfrm>
-            <a:off x="6675120" y="3840480"/>
+            <a:off x="6766560" y="3749040"/>
             <a:ext cx="4754880" cy="457200"/>
           </a:xfrm>
           <a:prstGeom prst="rect">
@@ -11298,20 +12002,20 @@
               </a:defRPr>
             </a:pPr>
             <a:r>
-              <a:t>- Biais dans les algorithmes et discrimination</a:t>
-            </a:r>
-          </a:p>
-        </p:txBody>
-      </p:sp>
-      <p:sp>
-        <p:nvSpPr>
-          <p:cNvPr id="18" name="TextBox 17"/>
+              <a:t>- Biais et discrimination algorithmique</a:t>
+            </a:r>
+          </a:p>
+        </p:txBody>
+      </p:sp>
+      <p:sp>
+        <p:nvSpPr>
+          <p:cNvPr id="20" name="TextBox 19"/>
           <p:cNvSpPr txBox="1"/>
           <p:nvPr/>
         </p:nvSpPr>
         <p:spPr>
           <a:xfrm>
-            <a:off x="6675120" y="4389120"/>
+            <a:off x="6766560" y="4343400"/>
             <a:ext cx="4754880" cy="457200"/>
           </a:xfrm>
           <a:prstGeom prst="rect">
@@ -11341,13 +12045,13 @@
       </p:sp>
       <p:sp>
         <p:nvSpPr>
-          <p:cNvPr id="19" name="TextBox 18"/>
+          <p:cNvPr id="21" name="TextBox 20"/>
           <p:cNvSpPr txBox="1"/>
           <p:nvPr/>
         </p:nvSpPr>
         <p:spPr>
           <a:xfrm>
-            <a:off x="6675120" y="4937760"/>
+            <a:off x="6766560" y="4937760"/>
             <a:ext cx="4754880" cy="457200"/>
           </a:xfrm>
           <a:prstGeom prst="rect">
@@ -11377,13 +12081,13 @@
       </p:sp>
       <p:sp>
         <p:nvSpPr>
-          <p:cNvPr id="20" name="TextBox 19"/>
+          <p:cNvPr id="22" name="TextBox 21"/>
           <p:cNvSpPr txBox="1"/>
           <p:nvPr/>
         </p:nvSpPr>
         <p:spPr>
           <a:xfrm>
-            <a:off x="6675120" y="5486400"/>
+            <a:off x="6766560" y="5532120"/>
             <a:ext cx="4754880" cy="457200"/>
           </a:xfrm>
           <a:prstGeom prst="rect">
@@ -11406,7 +12110,7 @@
               </a:defRPr>
             </a:pPr>
             <a:r>
-              <a:t>- Risques de mauvaise utilisation (deepfakes, armes)</a:t>
+              <a:t>- Deepfakes et desinformation</a:t>
             </a:r>
           </a:p>
         </p:txBody>

</xml_diff>